<commit_message>
docs(slides): thêm 2 slide vận hành giao việc Manager → Nhân viên
Chèn sau slide Báo cáo → Task: (1) Manager phân chia & giao việc (Gán task,
AI gợi ý người nhận, hạn, vòng đời 5 trạng thái); (2) Nhân viên nhận việc &
báo cáo hoàn thành lên quản lý (Việc của tôi, Nhận việc, RBAC). Ảnh UI thật
chụp từ tài khoản manager & staff. Deck: 15 → 17 slide.

Co-Authored-By: Claude Opus 4.8 <noreply@anthropic.com>
</commit_message>
<xml_diff>
--- a/docs/project/slides/AI-Quality-Intelligence-Platform-Overview.pptx
+++ b/docs/project/slides/AI-Quality-Intelligence-Platform-Overview.pptx
@@ -20,9 +20,11 @@
     <p:sldId id="268" r:id="rId14"/>
     <p:sldId id="269" r:id="rId15"/>
     <p:sldId id="270" r:id="rId16"/>
+    <p:sldId id="271" r:id="rId17"/>
+    <p:sldId id="272" r:id="rId18"/>
   </p:sldIdLst>
   <p:notesMasterIdLst>
-    <p:notesMasterId r:id="rId17"/>
+    <p:notesMasterId r:id="rId19"/>
   </p:notesMasterIdLst>
   <p:sldSz cx="9144000" cy="5143500"/>
   <p:notesSz cx="5143500" cy="9144000"/>
@@ -780,7 +782,7 @@
           <a:p>
             <a:r>
               <a:rPr lang="en-US" dirty="0"/>
-              <a:t>Hoạt động 6 — AI Chat với RAG hybrid. Trả lời có dẫn chứng từ SOP nội bộ; phân quyền tự động: guest chỉ thấy FAQ, staff thấy dữ liệu nội bộ.</a:t>
+              <a:t>Về vận hành giao việc: task gom từ ticket và báo cáo đã gắn sẵn phòng ban. Manager mở phần Gán task, hệ thống còn gợi ý người nhận cân bằng tải, rồi chọn nhân viên và đặt hạn để giao. Task đi qua năm trạng thái: đang mở, đã giao, đang xử lý, chờ duyệt, đã xong.</a:t>
             </a:r>
             <a:endParaRPr lang="en-US" dirty="0"/>
           </a:p>
@@ -868,7 +870,7 @@
           <a:p>
             <a:r>
               <a:rPr lang="en-US" dirty="0"/>
-              <a:t>Năm nguyên tắc sản phẩm này chi phối mọi quyết định thiết kế — đặc biệt là rút ngắn khoảng cách giữa một lời phàn nàn và một hành động khắc phục.</a:t>
+              <a:t>Phía nhân viên: với bộ lọc Việc của tôi, mỗi người chỉ thấy task được giao cho mình. Họ bấm Nhận việc để bắt đầu xử lý, rồi nộp báo cáo hoàn thành ở ba mức; task chuyển sang chờ duyệt để manager phê duyệt khép vòng. Giao diện cũng rút gọn đúng theo quyền.</a:t>
             </a:r>
             <a:endParaRPr lang="en-US" dirty="0"/>
           </a:p>
@@ -956,7 +958,7 @@
           <a:p>
             <a:r>
               <a:rPr lang="en-US" dirty="0"/>
-              <a:t>Hiện trạng: vòng khép kín đã hoàn thiện, chạy trên dữ liệu review tiếng Việt thật. Tiếp theo là mở rộng knowledge base cho 6 phòng và tinh chỉnh đánh giá.</a:t>
+              <a:t>Hoạt động 6 — AI Chat với RAG hybrid. Trả lời có dẫn chứng từ SOP nội bộ; phân quyền tự động: guest chỉ thấy FAQ, staff thấy dữ liệu nội bộ.</a:t>
             </a:r>
             <a:endParaRPr lang="en-US" dirty="0"/>
           </a:p>
@@ -1044,7 +1046,7 @@
           <a:p>
             <a:r>
               <a:rPr lang="en-US" dirty="0"/>
-              <a:t>Cảm ơn hội đồng. Em xin sẵn sàng cho phần hỏi đáp.</a:t>
+              <a:t>Năm nguyên tắc sản phẩm này chi phối mọi quyết định thiết kế — đặc biệt là rút ngắn khoảng cách giữa một lời phàn nàn và một hành động khắc phục.</a:t>
             </a:r>
             <a:endParaRPr lang="en-US" dirty="0"/>
           </a:p>
@@ -1068,6 +1070,182 @@
             <a:fld id="{F7021451-1387-4CA6-816F-3879F97B5CBC}" type="slidenum">
               <a:rPr lang="en-US"/>
               <a:t>15</a:t>
+            </a:fld>
+            <a:endParaRPr lang="en-US"/>
+          </a:p>
+        </p:txBody>
+      </p:sp>
+    </p:spTree>
+    <p:extLst>
+      <p:ext uri="{BB962C8B-B14F-4D97-AF65-F5344CB8AC3E}">
+        <p14:creationId xmlns:p14="http://schemas.microsoft.com/office/powerpoint/2010/main" val="1024086991"/>
+      </p:ext>
+    </p:extLst>
+  </p:cSld>
+  <p:clrMapOvr>
+    <a:masterClrMapping/>
+  </p:clrMapOvr>
+</p:notes>
+</file>
+
+<file path=ppt/notesSlides/notesSlide16.xml><?xml version="1.0" encoding="utf-8"?>
+<p:notes xmlns:a="http://schemas.openxmlformats.org/drawingml/2006/main" xmlns:r="http://schemas.openxmlformats.org/officeDocument/2006/relationships" xmlns:p="http://schemas.openxmlformats.org/presentationml/2006/main">
+  <p:cSld>
+    <p:spTree>
+      <p:nvGrpSpPr>
+        <p:cNvPr id="1" name=""/>
+        <p:cNvGrpSpPr/>
+        <p:nvPr/>
+      </p:nvGrpSpPr>
+      <p:grpSpPr>
+        <a:xfrm>
+          <a:off x="0" y="0"/>
+          <a:ext cx="0" cy="0"/>
+          <a:chOff x="0" y="0"/>
+          <a:chExt cx="0" cy="0"/>
+        </a:xfrm>
+      </p:grpSpPr>
+      <p:sp>
+        <p:nvSpPr>
+          <p:cNvPr id="2" name="Slide Image Placeholder 1"/>
+          <p:cNvSpPr>
+            <a:spLocks noGrp="1" noRot="1" noChangeAspect="1"/>
+          </p:cNvSpPr>
+          <p:nvPr>
+            <p:ph type="sldImg"/>
+          </p:nvPr>
+        </p:nvSpPr>
+        <p:spPr/>
+      </p:sp>
+      <p:sp>
+        <p:nvSpPr>
+          <p:cNvPr id="3" name="Notes Placeholder 2"/>
+          <p:cNvSpPr>
+            <a:spLocks noGrp="1"/>
+          </p:cNvSpPr>
+          <p:nvPr>
+            <p:ph type="body" idx="1"/>
+          </p:nvPr>
+        </p:nvSpPr>
+        <p:spPr/>
+        <p:txBody>
+          <a:bodyPr/>
+          <a:lstStyle/>
+          <a:p>
+            <a:r>
+              <a:rPr lang="en-US" dirty="0"/>
+              <a:t>Hiện trạng: vòng khép kín đã hoàn thiện, chạy trên dữ liệu review tiếng Việt thật. Tiếp theo là mở rộng knowledge base cho 6 phòng và tinh chỉnh đánh giá.</a:t>
+            </a:r>
+            <a:endParaRPr lang="en-US" dirty="0"/>
+          </a:p>
+        </p:txBody>
+      </p:sp>
+      <p:sp>
+        <p:nvSpPr>
+          <p:cNvPr id="4" name="Slide Number Placeholder 3"/>
+          <p:cNvSpPr>
+            <a:spLocks noGrp="1"/>
+          </p:cNvSpPr>
+          <p:nvPr>
+            <p:ph type="sldNum" sz="quarter" idx="10"/>
+          </p:nvPr>
+        </p:nvSpPr>
+        <p:spPr/>
+        <p:txBody>
+          <a:bodyPr/>
+          <a:lstStyle/>
+          <a:p>
+            <a:fld id="{F7021451-1387-4CA6-816F-3879F97B5CBC}" type="slidenum">
+              <a:rPr lang="en-US"/>
+              <a:t>16</a:t>
+            </a:fld>
+            <a:endParaRPr lang="en-US"/>
+          </a:p>
+        </p:txBody>
+      </p:sp>
+    </p:spTree>
+    <p:extLst>
+      <p:ext uri="{BB962C8B-B14F-4D97-AF65-F5344CB8AC3E}">
+        <p14:creationId xmlns:p14="http://schemas.microsoft.com/office/powerpoint/2010/main" val="1024086991"/>
+      </p:ext>
+    </p:extLst>
+  </p:cSld>
+  <p:clrMapOvr>
+    <a:masterClrMapping/>
+  </p:clrMapOvr>
+</p:notes>
+</file>
+
+<file path=ppt/notesSlides/notesSlide17.xml><?xml version="1.0" encoding="utf-8"?>
+<p:notes xmlns:a="http://schemas.openxmlformats.org/drawingml/2006/main" xmlns:r="http://schemas.openxmlformats.org/officeDocument/2006/relationships" xmlns:p="http://schemas.openxmlformats.org/presentationml/2006/main">
+  <p:cSld>
+    <p:spTree>
+      <p:nvGrpSpPr>
+        <p:cNvPr id="1" name=""/>
+        <p:cNvGrpSpPr/>
+        <p:nvPr/>
+      </p:nvGrpSpPr>
+      <p:grpSpPr>
+        <a:xfrm>
+          <a:off x="0" y="0"/>
+          <a:ext cx="0" cy="0"/>
+          <a:chOff x="0" y="0"/>
+          <a:chExt cx="0" cy="0"/>
+        </a:xfrm>
+      </p:grpSpPr>
+      <p:sp>
+        <p:nvSpPr>
+          <p:cNvPr id="2" name="Slide Image Placeholder 1"/>
+          <p:cNvSpPr>
+            <a:spLocks noGrp="1" noRot="1" noChangeAspect="1"/>
+          </p:cNvSpPr>
+          <p:nvPr>
+            <p:ph type="sldImg"/>
+          </p:nvPr>
+        </p:nvSpPr>
+        <p:spPr/>
+      </p:sp>
+      <p:sp>
+        <p:nvSpPr>
+          <p:cNvPr id="3" name="Notes Placeholder 2"/>
+          <p:cNvSpPr>
+            <a:spLocks noGrp="1"/>
+          </p:cNvSpPr>
+          <p:nvPr>
+            <p:ph type="body" idx="1"/>
+          </p:nvPr>
+        </p:nvSpPr>
+        <p:spPr/>
+        <p:txBody>
+          <a:bodyPr/>
+          <a:lstStyle/>
+          <a:p>
+            <a:r>
+              <a:rPr lang="en-US" dirty="0"/>
+              <a:t>Cảm ơn hội đồng. Em xin sẵn sàng cho phần hỏi đáp.</a:t>
+            </a:r>
+            <a:endParaRPr lang="en-US" dirty="0"/>
+          </a:p>
+        </p:txBody>
+      </p:sp>
+      <p:sp>
+        <p:nvSpPr>
+          <p:cNvPr id="4" name="Slide Number Placeholder 3"/>
+          <p:cNvSpPr>
+            <a:spLocks noGrp="1"/>
+          </p:cNvSpPr>
+          <p:nvPr>
+            <p:ph type="sldNum" sz="quarter" idx="10"/>
+          </p:nvPr>
+        </p:nvSpPr>
+        <p:spPr/>
+        <p:txBody>
+          <a:bodyPr/>
+          <a:lstStyle/>
+          <a:p>
+            <a:fld id="{F7021451-1387-4CA6-816F-3879F97B5CBC}" type="slidenum">
+              <a:rPr lang="en-US"/>
+              <a:t>17</a:t>
             </a:fld>
             <a:endParaRPr lang="en-US"/>
           </a:p>
@@ -3424,7 +3602,7 @@
         <p:spPr>
           <a:xfrm>
             <a:off x="381000" y="330101"/>
-            <a:ext cx="8549640" cy="200025"/>
+            <a:ext cx="8549640" cy="142875"/>
           </a:xfrm>
           <a:prstGeom prst="rect">
             <a:avLst/>
@@ -3451,7 +3629,7 @@
                 <a:ea typeface="Arial" pitchFamily="34" charset="-122"/>
                 <a:cs typeface="Arial" pitchFamily="34" charset="-120"/>
               </a:rPr>
-              <a:t>CÁCH HOẠT ĐỘNG ⑥</a:t>
+              <a:t>VẬN HÀNH · GIAO VIỆC</a:t>
             </a:r>
             <a:endParaRPr lang="en-US" sz="1000" dirty="0"/>
           </a:p>
@@ -3465,7 +3643,7 @@
         </p:nvSpPr>
         <p:spPr>
           <a:xfrm>
-            <a:off x="381000" y="580876"/>
+            <a:off x="381000" y="523726"/>
             <a:ext cx="8549640" cy="342751"/>
           </a:xfrm>
           <a:prstGeom prst="rect">
@@ -3493,7 +3671,7 @@
                 <a:ea typeface="Arial" pitchFamily="34" charset="-122"/>
                 <a:cs typeface="Arial" pitchFamily="34" charset="-120"/>
               </a:rPr>
-              <a:t>AI Chat + RAG Hybrid, phân quyền theo vai trò</a:t>
+              <a:t>Manager phân chia &amp; giao việc cho nhân viên</a:t>
             </a:r>
             <a:endParaRPr lang="en-US" sz="2500" dirty="0"/>
           </a:p>
@@ -3507,7 +3685,7 @@
         </p:nvSpPr>
         <p:spPr>
           <a:xfrm>
-            <a:off x="381000" y="1152227"/>
+            <a:off x="381000" y="1095077"/>
             <a:ext cx="3048149" cy="1946672"/>
           </a:xfrm>
           <a:prstGeom prst="rect">
@@ -3539,7 +3717,7 @@
                 <a:ea typeface="Arial" pitchFamily="34" charset="-122"/>
                 <a:cs typeface="Arial" pitchFamily="34" charset="-120"/>
               </a:rPr>
-              <a:t>Hybrid Search: </a:t>
+              <a:t>Task gom từ ticket/báo cáo, </a:t>
             </a:r>
             <a:pPr algn="l" indent="0" marL="0">
               <a:lnSpc>
@@ -3559,7 +3737,7 @@
                 <a:ea typeface="Arial" pitchFamily="34" charset="-122"/>
                 <a:cs typeface="Arial" pitchFamily="34" charset="-120"/>
               </a:rPr>
-              <a:t>Cohere embed-multilingual-v3 + BM25-lite + RRF (k=60)</a:t>
+              <a:t>gắn sẵn phòng ban</a:t>
             </a:r>
             <a:pPr algn="l" indent="0" marL="0">
               <a:lnSpc>
@@ -3579,7 +3757,7 @@
                 <a:ea typeface="Arial" pitchFamily="34" charset="-122"/>
                 <a:cs typeface="Arial" pitchFamily="34" charset="-120"/>
               </a:rPr>
-              <a:t>.</a:t>
+              <a:t> phụ trách.</a:t>
             </a:r>
             <a:endParaRPr lang="en-US" sz="1150" dirty="0"/>
           </a:p>
@@ -3603,7 +3781,7 @@
                 <a:ea typeface="Arial" pitchFamily="34" charset="-122"/>
                 <a:cs typeface="Arial" pitchFamily="34" charset="-120"/>
               </a:rPr>
-              <a:t>Trả lời có dẫn chứng — trích </a:t>
+              <a:t>Mở </a:t>
             </a:r>
             <a:pPr algn="l" indent="0" marL="0">
               <a:lnSpc>
@@ -3623,7 +3801,7 @@
                 <a:ea typeface="Arial" pitchFamily="34" charset="-122"/>
                 <a:cs typeface="Arial" pitchFamily="34" charset="-120"/>
               </a:rPr>
-              <a:t>SOP nội bộ</a:t>
+              <a:t>"Gán task"</a:t>
             </a:r>
             <a:pPr algn="l" indent="0" marL="0">
               <a:lnSpc>
@@ -3643,7 +3821,47 @@
                 <a:ea typeface="Arial" pitchFamily="34" charset="-122"/>
                 <a:cs typeface="Arial" pitchFamily="34" charset="-120"/>
               </a:rPr>
-              <a:t> và bảng dữ liệu thật.</a:t>
+              <a:t> — AI </a:t>
+            </a:r>
+            <a:pPr algn="l" indent="0" marL="0">
+              <a:lnSpc>
+                <a:spcPts val="1667"/>
+              </a:lnSpc>
+              <a:spcAft>
+                <a:spcPts val="500"/>
+              </a:spcAft>
+              <a:buNone/>
+            </a:pPr>
+            <a:r>
+              <a:rPr lang="en-US" sz="1150" b="1" dirty="0">
+                <a:solidFill>
+                  <a:srgbClr val="0E2B29"/>
+                </a:solidFill>
+                <a:latin typeface="Arial" pitchFamily="34" charset="0"/>
+                <a:ea typeface="Arial" pitchFamily="34" charset="-122"/>
+                <a:cs typeface="Arial" pitchFamily="34" charset="-120"/>
+              </a:rPr>
+              <a:t>gợi ý người nhận</a:t>
+            </a:r>
+            <a:pPr algn="l" indent="0" marL="0">
+              <a:lnSpc>
+                <a:spcPts val="1667"/>
+              </a:lnSpc>
+              <a:spcAft>
+                <a:spcPts val="500"/>
+              </a:spcAft>
+              <a:buNone/>
+            </a:pPr>
+            <a:r>
+              <a:rPr lang="en-US" sz="1150" dirty="0">
+                <a:solidFill>
+                  <a:srgbClr val="0E2B29"/>
+                </a:solidFill>
+                <a:latin typeface="Arial" pitchFamily="34" charset="0"/>
+                <a:ea typeface="Arial" pitchFamily="34" charset="-122"/>
+                <a:cs typeface="Arial" pitchFamily="34" charset="-120"/>
+              </a:rPr>
+              <a:t> cân bằng tải trong phòng.</a:t>
             </a:r>
             <a:endParaRPr lang="en-US" sz="1150" dirty="0"/>
           </a:p>
@@ -3667,7 +3885,7 @@
                 <a:ea typeface="Arial" pitchFamily="34" charset="-122"/>
                 <a:cs typeface="Arial" pitchFamily="34" charset="-120"/>
               </a:rPr>
-              <a:t>Phân quyền tự động: </a:t>
+              <a:t>Chọn nhân viên + đặt </a:t>
             </a:r>
             <a:pPr algn="l" indent="0" marL="0">
               <a:lnSpc>
@@ -3687,7 +3905,7 @@
                 <a:ea typeface="Arial" pitchFamily="34" charset="-122"/>
                 <a:cs typeface="Arial" pitchFamily="34" charset="-120"/>
               </a:rPr>
-              <a:t>Guest</a:t>
+              <a:t>hạn hoàn thành</a:t>
             </a:r>
             <a:pPr algn="l" indent="0" marL="0">
               <a:lnSpc>
@@ -3707,7 +3925,7 @@
                 <a:ea typeface="Arial" pitchFamily="34" charset="-122"/>
                 <a:cs typeface="Arial" pitchFamily="34" charset="-120"/>
               </a:rPr>
-              <a:t> chỉ FAQ công khai, </a:t>
+              <a:t> → bấm </a:t>
             </a:r>
             <a:pPr algn="l" indent="0" marL="0">
               <a:lnSpc>
@@ -3727,7 +3945,7 @@
                 <a:ea typeface="Arial" pitchFamily="34" charset="-122"/>
                 <a:cs typeface="Arial" pitchFamily="34" charset="-120"/>
               </a:rPr>
-              <a:t>Staff</a:t>
+              <a:t>Gán</a:t>
             </a:r>
             <a:pPr algn="l" indent="0" marL="0">
               <a:lnSpc>
@@ -3747,7 +3965,7 @@
                 <a:ea typeface="Arial" pitchFamily="34" charset="-122"/>
                 <a:cs typeface="Arial" pitchFamily="34" charset="-120"/>
               </a:rPr>
-              <a:t> thấy nội bộ.</a:t>
+              <a:t>.</a:t>
             </a:r>
             <a:endParaRPr lang="en-US" sz="1150" dirty="0"/>
           </a:p>
@@ -3771,7 +3989,47 @@
                 <a:ea typeface="Arial" pitchFamily="34" charset="-122"/>
                 <a:cs typeface="Arial" pitchFamily="34" charset="-120"/>
               </a:rPr>
-              <a:t>Cùng một giao diện chat — quyền truy cập đổi theo role.</a:t>
+              <a:t>Vòng đời: </a:t>
+            </a:r>
+            <a:pPr algn="l" indent="0" marL="0">
+              <a:lnSpc>
+                <a:spcPts val="1667"/>
+              </a:lnSpc>
+              <a:spcAft>
+                <a:spcPts val="500"/>
+              </a:spcAft>
+              <a:buNone/>
+            </a:pPr>
+            <a:r>
+              <a:rPr lang="en-US" sz="1150" b="1" dirty="0">
+                <a:solidFill>
+                  <a:srgbClr val="0E2B29"/>
+                </a:solidFill>
+                <a:latin typeface="Arial" pitchFamily="34" charset="0"/>
+                <a:ea typeface="Arial" pitchFamily="34" charset="-122"/>
+                <a:cs typeface="Arial" pitchFamily="34" charset="-120"/>
+              </a:rPr>
+              <a:t>Đang mở → Đã giao → Đang xử lý → Chờ duyệt → Đã xong</a:t>
+            </a:r>
+            <a:pPr algn="l" indent="0" marL="0">
+              <a:lnSpc>
+                <a:spcPts val="1667"/>
+              </a:lnSpc>
+              <a:spcAft>
+                <a:spcPts val="500"/>
+              </a:spcAft>
+              <a:buNone/>
+            </a:pPr>
+            <a:r>
+              <a:rPr lang="en-US" sz="1150" dirty="0">
+                <a:solidFill>
+                  <a:srgbClr val="0E2B29"/>
+                </a:solidFill>
+                <a:latin typeface="Arial" pitchFamily="34" charset="0"/>
+                <a:ea typeface="Arial" pitchFamily="34" charset="-122"/>
+                <a:cs typeface="Arial" pitchFamily="34" charset="-120"/>
+              </a:rPr>
+              <a:t>.</a:t>
             </a:r>
             <a:endParaRPr lang="en-US" sz="1150" dirty="0"/>
           </a:p>
@@ -3785,7 +4043,7 @@
         </p:nvSpPr>
         <p:spPr>
           <a:xfrm>
-            <a:off x="3632299" y="1076027"/>
+            <a:off x="3632299" y="1018877"/>
             <a:ext cx="5130701" cy="3262759"/>
           </a:xfrm>
           <a:prstGeom prst="roundRect">
@@ -3822,7 +4080,7 @@
       </p:sp>
       <p:pic>
         <p:nvPicPr>
-          <p:cNvPr id="6" name="Image 0" descr="/private/tmp/claude-501/-Users-kenz-de-projects-C2-App-116/3d8df5ac-6b2b-4cce-a997-fe0b4573b465/scratchpad/build/assets/chat.png">    </p:cNvPr>
+          <p:cNvPr id="6" name="Image 0" descr="/private/tmp/claude-501/-Users-kenz-de-projects-C2-App-116/3d8df5ac-6b2b-4cce-a997-fe0b4573b465/scratchpad/build/assets/manager.png">    </p:cNvPr>
           <p:cNvPicPr>
             <a:picLocks noChangeAspect="1"/>
           </p:cNvPicPr>
@@ -3836,7 +4094,7 @@
         </p:blipFill>
         <p:spPr>
           <a:xfrm>
-            <a:off x="3705225" y="1148953"/>
+            <a:off x="3705225" y="1091803"/>
             <a:ext cx="4984849" cy="3116907"/>
           </a:xfrm>
           <a:prstGeom prst="rect">
@@ -3954,7 +4212,7 @@
                 <a:ea typeface="Arial" pitchFamily="34" charset="-122"/>
                 <a:cs typeface="Arial" pitchFamily="34" charset="-120"/>
               </a:rPr>
-              <a:t>TƯ DUY SẢN PHẨM</a:t>
+              <a:t>VẬN HÀNH · NHÂN VIÊN</a:t>
             </a:r>
             <a:endParaRPr lang="en-US" sz="1000" dirty="0"/>
           </a:p>
@@ -3996,7 +4254,7 @@
                 <a:ea typeface="Arial" pitchFamily="34" charset="-122"/>
                 <a:cs typeface="Arial" pitchFamily="34" charset="-120"/>
               </a:rPr>
-              <a:t>Năm nguyên tắc định hình mọi quyết định</a:t>
+              <a:t>Nhân viên nhận việc, xử lý &amp; báo cáo lên quản lý</a:t>
             </a:r>
             <a:endParaRPr lang="en-US" sz="2500" dirty="0"/>
           </a:p>
@@ -4010,271 +4268,367 @@
         </p:nvSpPr>
         <p:spPr>
           <a:xfrm>
-            <a:off x="381000" y="1069628"/>
-            <a:ext cx="1554361" cy="2686050"/>
+            <a:off x="381000" y="1095077"/>
+            <a:ext cx="3048149" cy="1946672"/>
+          </a:xfrm>
+          <a:prstGeom prst="rect">
+            <a:avLst/>
+          </a:prstGeom>
+          <a:noFill/>
+          <a:ln/>
+        </p:spPr>
+        <p:txBody>
+          <a:bodyPr wrap="square" lIns="88900" tIns="0" rIns="0" bIns="0" rtlCol="0" anchor="t"/>
+          <a:lstStyle/>
+          <a:p>
+            <a:pPr algn="l" marL="88900" indent="-88900">
+              <a:lnSpc>
+                <a:spcPts val="1667"/>
+              </a:lnSpc>
+              <a:spcAft>
+                <a:spcPts val="500"/>
+              </a:spcAft>
+              <a:buSzPct val="100000"/>
+              <a:buChar char="•"/>
+            </a:pPr>
+            <a:r>
+              <a:rPr lang="en-US" sz="1150" b="1" dirty="0">
+                <a:solidFill>
+                  <a:srgbClr val="0E2B29"/>
+                </a:solidFill>
+                <a:latin typeface="Arial" pitchFamily="34" charset="0"/>
+                <a:ea typeface="Arial" pitchFamily="34" charset="-122"/>
+                <a:cs typeface="Arial" pitchFamily="34" charset="-120"/>
+              </a:rPr>
+              <a:t>"Việc của tôi":</a:t>
+            </a:r>
+            <a:pPr algn="l" indent="0" marL="0">
+              <a:lnSpc>
+                <a:spcPts val="1667"/>
+              </a:lnSpc>
+              <a:spcAft>
+                <a:spcPts val="500"/>
+              </a:spcAft>
+              <a:buNone/>
+            </a:pPr>
+            <a:r>
+              <a:rPr lang="en-US" sz="1150" dirty="0">
+                <a:solidFill>
+                  <a:srgbClr val="0E2B29"/>
+                </a:solidFill>
+                <a:latin typeface="Arial" pitchFamily="34" charset="0"/>
+                <a:ea typeface="Arial" pitchFamily="34" charset="-122"/>
+                <a:cs typeface="Arial" pitchFamily="34" charset="-120"/>
+              </a:rPr>
+              <a:t> chỉ thấy task được giao cho mình (lọc theo phòng + người nhận).</a:t>
+            </a:r>
+            <a:endParaRPr lang="en-US" sz="1150" dirty="0"/>
+          </a:p>
+          <a:p>
+            <a:pPr algn="l" marL="88900" indent="-88900">
+              <a:lnSpc>
+                <a:spcPts val="1667"/>
+              </a:lnSpc>
+              <a:spcAft>
+                <a:spcPts val="500"/>
+              </a:spcAft>
+              <a:buSzPct val="100000"/>
+              <a:buChar char="•"/>
+            </a:pPr>
+            <a:r>
+              <a:rPr lang="en-US" sz="1150" dirty="0">
+                <a:solidFill>
+                  <a:srgbClr val="0E2B29"/>
+                </a:solidFill>
+                <a:latin typeface="Arial" pitchFamily="34" charset="0"/>
+                <a:ea typeface="Arial" pitchFamily="34" charset="-122"/>
+                <a:cs typeface="Arial" pitchFamily="34" charset="-120"/>
+              </a:rPr>
+              <a:t>Bấm </a:t>
+            </a:r>
+            <a:pPr algn="l" indent="0" marL="0">
+              <a:lnSpc>
+                <a:spcPts val="1667"/>
+              </a:lnSpc>
+              <a:spcAft>
+                <a:spcPts val="500"/>
+              </a:spcAft>
+              <a:buNone/>
+            </a:pPr>
+            <a:r>
+              <a:rPr lang="en-US" sz="1150" b="1" dirty="0">
+                <a:solidFill>
+                  <a:srgbClr val="0E2B29"/>
+                </a:solidFill>
+                <a:latin typeface="Arial" pitchFamily="34" charset="0"/>
+                <a:ea typeface="Arial" pitchFamily="34" charset="-122"/>
+                <a:cs typeface="Arial" pitchFamily="34" charset="-120"/>
+              </a:rPr>
+              <a:t>"Nhận việc"</a:t>
+            </a:r>
+            <a:pPr algn="l" indent="0" marL="0">
+              <a:lnSpc>
+                <a:spcPts val="1667"/>
+              </a:lnSpc>
+              <a:spcAft>
+                <a:spcPts val="500"/>
+              </a:spcAft>
+              <a:buNone/>
+            </a:pPr>
+            <a:r>
+              <a:rPr lang="en-US" sz="1150" dirty="0">
+                <a:solidFill>
+                  <a:srgbClr val="0E2B29"/>
+                </a:solidFill>
+                <a:latin typeface="Arial" pitchFamily="34" charset="0"/>
+                <a:ea typeface="Arial" pitchFamily="34" charset="-122"/>
+                <a:cs typeface="Arial" pitchFamily="34" charset="-120"/>
+              </a:rPr>
+              <a:t> → task chuyển sang </a:t>
+            </a:r>
+            <a:pPr algn="l" indent="0" marL="0">
+              <a:lnSpc>
+                <a:spcPts val="1667"/>
+              </a:lnSpc>
+              <a:spcAft>
+                <a:spcPts val="500"/>
+              </a:spcAft>
+              <a:buNone/>
+            </a:pPr>
+            <a:r>
+              <a:rPr lang="en-US" sz="1150" b="1" dirty="0">
+                <a:solidFill>
+                  <a:srgbClr val="0E2B29"/>
+                </a:solidFill>
+                <a:latin typeface="Arial" pitchFamily="34" charset="0"/>
+                <a:ea typeface="Arial" pitchFamily="34" charset="-122"/>
+                <a:cs typeface="Arial" pitchFamily="34" charset="-120"/>
+              </a:rPr>
+              <a:t>Đang xử lý</a:t>
+            </a:r>
+            <a:pPr algn="l" indent="0" marL="0">
+              <a:lnSpc>
+                <a:spcPts val="1667"/>
+              </a:lnSpc>
+              <a:spcAft>
+                <a:spcPts val="500"/>
+              </a:spcAft>
+              <a:buNone/>
+            </a:pPr>
+            <a:r>
+              <a:rPr lang="en-US" sz="1150" dirty="0">
+                <a:solidFill>
+                  <a:srgbClr val="0E2B29"/>
+                </a:solidFill>
+                <a:latin typeface="Arial" pitchFamily="34" charset="0"/>
+                <a:ea typeface="Arial" pitchFamily="34" charset="-122"/>
+                <a:cs typeface="Arial" pitchFamily="34" charset="-120"/>
+              </a:rPr>
+              <a:t>.</a:t>
+            </a:r>
+            <a:endParaRPr lang="en-US" sz="1150" dirty="0"/>
+          </a:p>
+          <a:p>
+            <a:pPr algn="l" marL="88900" indent="-88900">
+              <a:lnSpc>
+                <a:spcPts val="1667"/>
+              </a:lnSpc>
+              <a:spcAft>
+                <a:spcPts val="500"/>
+              </a:spcAft>
+              <a:buSzPct val="100000"/>
+              <a:buChar char="•"/>
+            </a:pPr>
+            <a:r>
+              <a:rPr lang="en-US" sz="1150" dirty="0">
+                <a:solidFill>
+                  <a:srgbClr val="0E2B29"/>
+                </a:solidFill>
+                <a:latin typeface="Arial" pitchFamily="34" charset="0"/>
+                <a:ea typeface="Arial" pitchFamily="34" charset="-122"/>
+                <a:cs typeface="Arial" pitchFamily="34" charset="-120"/>
+              </a:rPr>
+              <a:t>Nộp </a:t>
+            </a:r>
+            <a:pPr algn="l" indent="0" marL="0">
+              <a:lnSpc>
+                <a:spcPts val="1667"/>
+              </a:lnSpc>
+              <a:spcAft>
+                <a:spcPts val="500"/>
+              </a:spcAft>
+              <a:buNone/>
+            </a:pPr>
+            <a:r>
+              <a:rPr lang="en-US" sz="1150" b="1" dirty="0">
+                <a:solidFill>
+                  <a:srgbClr val="0E2B29"/>
+                </a:solidFill>
+                <a:latin typeface="Arial" pitchFamily="34" charset="0"/>
+                <a:ea typeface="Arial" pitchFamily="34" charset="-122"/>
+                <a:cs typeface="Arial" pitchFamily="34" charset="-120"/>
+              </a:rPr>
+              <a:t>Báo cáo hoàn thành</a:t>
+            </a:r>
+            <a:pPr algn="l" indent="0" marL="0">
+              <a:lnSpc>
+                <a:spcPts val="1667"/>
+              </a:lnSpc>
+              <a:spcAft>
+                <a:spcPts val="500"/>
+              </a:spcAft>
+              <a:buNone/>
+            </a:pPr>
+            <a:r>
+              <a:rPr lang="en-US" sz="1150" dirty="0">
+                <a:solidFill>
+                  <a:srgbClr val="0E2B29"/>
+                </a:solidFill>
+                <a:latin typeface="Arial" pitchFamily="34" charset="0"/>
+                <a:ea typeface="Arial" pitchFamily="34" charset="-122"/>
+                <a:cs typeface="Arial" pitchFamily="34" charset="-120"/>
+              </a:rPr>
+              <a:t> (Hoàn thành / Một phần / Bị chặn) → task </a:t>
+            </a:r>
+            <a:pPr algn="l" indent="0" marL="0">
+              <a:lnSpc>
+                <a:spcPts val="1667"/>
+              </a:lnSpc>
+              <a:spcAft>
+                <a:spcPts val="500"/>
+              </a:spcAft>
+              <a:buNone/>
+            </a:pPr>
+            <a:r>
+              <a:rPr lang="en-US" sz="1150" b="1" dirty="0">
+                <a:solidFill>
+                  <a:srgbClr val="0E2B29"/>
+                </a:solidFill>
+                <a:latin typeface="Arial" pitchFamily="34" charset="0"/>
+                <a:ea typeface="Arial" pitchFamily="34" charset="-122"/>
+                <a:cs typeface="Arial" pitchFamily="34" charset="-120"/>
+              </a:rPr>
+              <a:t>Chờ duyệt</a:t>
+            </a:r>
+            <a:pPr algn="l" indent="0" marL="0">
+              <a:lnSpc>
+                <a:spcPts val="1667"/>
+              </a:lnSpc>
+              <a:spcAft>
+                <a:spcPts val="500"/>
+              </a:spcAft>
+              <a:buNone/>
+            </a:pPr>
+            <a:r>
+              <a:rPr lang="en-US" sz="1150" dirty="0">
+                <a:solidFill>
+                  <a:srgbClr val="0E2B29"/>
+                </a:solidFill>
+                <a:latin typeface="Arial" pitchFamily="34" charset="0"/>
+                <a:ea typeface="Arial" pitchFamily="34" charset="-122"/>
+                <a:cs typeface="Arial" pitchFamily="34" charset="-120"/>
+              </a:rPr>
+              <a:t>.</a:t>
+            </a:r>
+            <a:endParaRPr lang="en-US" sz="1150" dirty="0"/>
+          </a:p>
+          <a:p>
+            <a:pPr algn="l" marL="88900" indent="-88900">
+              <a:lnSpc>
+                <a:spcPts val="1667"/>
+              </a:lnSpc>
+              <a:spcAft>
+                <a:spcPts val="500"/>
+              </a:spcAft>
+              <a:buSzPct val="100000"/>
+              <a:buChar char="•"/>
+            </a:pPr>
+            <a:r>
+              <a:rPr lang="en-US" sz="1150" dirty="0">
+                <a:solidFill>
+                  <a:srgbClr val="0E2B29"/>
+                </a:solidFill>
+                <a:latin typeface="Arial" pitchFamily="34" charset="0"/>
+                <a:ea typeface="Arial" pitchFamily="34" charset="-122"/>
+                <a:cs typeface="Arial" pitchFamily="34" charset="-120"/>
+              </a:rPr>
+              <a:t>Manager </a:t>
+            </a:r>
+            <a:pPr algn="l" indent="0" marL="0">
+              <a:lnSpc>
+                <a:spcPts val="1667"/>
+              </a:lnSpc>
+              <a:spcAft>
+                <a:spcPts val="500"/>
+              </a:spcAft>
+              <a:buNone/>
+            </a:pPr>
+            <a:r>
+              <a:rPr lang="en-US" sz="1150" b="1" dirty="0">
+                <a:solidFill>
+                  <a:srgbClr val="0E2B29"/>
+                </a:solidFill>
+                <a:latin typeface="Arial" pitchFamily="34" charset="0"/>
+                <a:ea typeface="Arial" pitchFamily="34" charset="-122"/>
+                <a:cs typeface="Arial" pitchFamily="34" charset="-120"/>
+              </a:rPr>
+              <a:t>duyệt</a:t>
+            </a:r>
+            <a:pPr algn="l" indent="0" marL="0">
+              <a:lnSpc>
+                <a:spcPts val="1667"/>
+              </a:lnSpc>
+              <a:spcAft>
+                <a:spcPts val="500"/>
+              </a:spcAft>
+              <a:buNone/>
+            </a:pPr>
+            <a:r>
+              <a:rPr lang="en-US" sz="1150" dirty="0">
+                <a:solidFill>
+                  <a:srgbClr val="0E2B29"/>
+                </a:solidFill>
+                <a:latin typeface="Arial" pitchFamily="34" charset="0"/>
+                <a:ea typeface="Arial" pitchFamily="34" charset="-122"/>
+                <a:cs typeface="Arial" pitchFamily="34" charset="-120"/>
+              </a:rPr>
+              <a:t> để khép vòng; giao diện rút gọn đúng quyền (RBAC).</a:t>
+            </a:r>
+            <a:endParaRPr lang="en-US" sz="1150" dirty="0"/>
+          </a:p>
+        </p:txBody>
+      </p:sp>
+      <p:sp>
+        <p:nvSpPr>
+          <p:cNvPr id="5" name="Text 3"/>
+          <p:cNvSpPr/>
+          <p:nvPr/>
+        </p:nvSpPr>
+        <p:spPr>
+          <a:xfrm>
+            <a:off x="3632299" y="1018877"/>
+            <a:ext cx="5130701" cy="3262759"/>
           </a:xfrm>
           <a:prstGeom prst="roundRect">
             <a:avLst>
-              <a:gd name="adj" fmla="val 8171"/>
+              <a:gd name="adj" fmla="val 3892"/>
             </a:avLst>
           </a:prstGeom>
           <a:solidFill>
             <a:srgbClr val="FFFFFF"/>
           </a:solidFill>
-          <a:ln/>
-        </p:spPr>
-        <p:txBody>
-          <a:bodyPr wrap="square" rtlCol="0" anchor="ctr"/>
-          <a:lstStyle/>
-          <a:p>
-            <a:pPr indent="0" marL="0">
-              <a:buNone/>
-            </a:pPr>
-            <a:endParaRPr lang="en-US" dirty="0"/>
-          </a:p>
-        </p:txBody>
-      </p:sp>
-      <p:sp>
-        <p:nvSpPr>
-          <p:cNvPr id="5" name="Shape 3"/>
-          <p:cNvSpPr/>
-          <p:nvPr/>
-        </p:nvSpPr>
-        <p:spPr>
-          <a:xfrm>
-            <a:off x="381000" y="1093440"/>
-            <a:ext cx="1554361" cy="0"/>
-          </a:xfrm>
-          <a:prstGeom prst="line">
-            <a:avLst/>
-          </a:prstGeom>
-          <a:noFill/>
-          <a:ln w="47625">
-            <a:solidFill>
-              <a:srgbClr val="0E8C84"/>
-            </a:solidFill>
-            <a:prstDash val="solid"/>
-          </a:ln>
-        </p:spPr>
-      </p:sp>
-      <p:sp>
-        <p:nvSpPr>
-          <p:cNvPr id="6" name="Shape 4"/>
-          <p:cNvSpPr/>
-          <p:nvPr/>
-        </p:nvSpPr>
-        <p:spPr>
-          <a:xfrm>
-            <a:off x="1930598" y="1069628"/>
-            <a:ext cx="0" cy="2686050"/>
-          </a:xfrm>
-          <a:prstGeom prst="line">
-            <a:avLst/>
-          </a:prstGeom>
-          <a:noFill/>
           <a:ln w="9525">
             <a:solidFill>
               <a:srgbClr val="D9E8E4"/>
             </a:solidFill>
-            <a:prstDash val="solid"/>
           </a:ln>
-        </p:spPr>
-      </p:sp>
-      <p:sp>
-        <p:nvSpPr>
-          <p:cNvPr id="7" name="Shape 5"/>
-          <p:cNvSpPr/>
-          <p:nvPr/>
-        </p:nvSpPr>
-        <p:spPr>
-          <a:xfrm>
-            <a:off x="381000" y="3750915"/>
-            <a:ext cx="1554361" cy="0"/>
-          </a:xfrm>
-          <a:prstGeom prst="line">
-            <a:avLst/>
-          </a:prstGeom>
-          <a:noFill/>
-          <a:ln w="9525">
-            <a:solidFill>
-              <a:srgbClr val="D9E8E4"/>
-            </a:solidFill>
-            <a:prstDash val="solid"/>
-          </a:ln>
-        </p:spPr>
-      </p:sp>
-      <p:sp>
-        <p:nvSpPr>
-          <p:cNvPr id="8" name="Shape 6"/>
-          <p:cNvSpPr/>
-          <p:nvPr/>
-        </p:nvSpPr>
-        <p:spPr>
-          <a:xfrm>
-            <a:off x="385763" y="1069628"/>
-            <a:ext cx="0" cy="2686050"/>
-          </a:xfrm>
-          <a:prstGeom prst="line">
-            <a:avLst/>
-          </a:prstGeom>
-          <a:noFill/>
-          <a:ln w="9525">
-            <a:solidFill>
-              <a:srgbClr val="D9E8E4"/>
-            </a:solidFill>
-            <a:prstDash val="solid"/>
-          </a:ln>
-        </p:spPr>
-      </p:sp>
-      <p:sp>
-        <p:nvSpPr>
-          <p:cNvPr id="9" name="Text 7"/>
-          <p:cNvSpPr/>
-          <p:nvPr/>
-        </p:nvSpPr>
-        <p:spPr>
-          <a:xfrm>
-            <a:off x="542925" y="1269653"/>
-            <a:ext cx="1255121" cy="238125"/>
-          </a:xfrm>
-          <a:prstGeom prst="rect">
-            <a:avLst/>
-          </a:prstGeom>
-          <a:noFill/>
-          <a:ln/>
-        </p:spPr>
-        <p:txBody>
-          <a:bodyPr wrap="square" lIns="0" tIns="0" rIns="0" bIns="0" rtlCol="0" anchor="t"/>
-          <a:lstStyle/>
-          <a:p>
-            <a:pPr algn="l" indent="0" marL="0">
-              <a:buNone/>
-            </a:pPr>
-            <a:r>
-              <a:rPr lang="en-US" sz="1600" b="1" dirty="0">
-                <a:solidFill>
-                  <a:srgbClr val="34D399"/>
-                </a:solidFill>
-                <a:latin typeface="Arial" pitchFamily="34" charset="0"/>
-                <a:ea typeface="Arial" pitchFamily="34" charset="-122"/>
-                <a:cs typeface="Arial" pitchFamily="34" charset="-120"/>
-              </a:rPr>
-              <a:t>01</a:t>
-            </a:r>
-            <a:endParaRPr lang="en-US" sz="1600" dirty="0"/>
-          </a:p>
-        </p:txBody>
-      </p:sp>
-      <p:sp>
-        <p:nvSpPr>
-          <p:cNvPr id="10" name="Text 8"/>
-          <p:cNvSpPr/>
-          <p:nvPr/>
-        </p:nvSpPr>
-        <p:spPr>
-          <a:xfrm>
-            <a:off x="542925" y="1571179"/>
-            <a:ext cx="1255121" cy="349151"/>
-          </a:xfrm>
-          <a:prstGeom prst="rect">
-            <a:avLst/>
-          </a:prstGeom>
-          <a:noFill/>
-          <a:ln/>
-        </p:spPr>
-        <p:txBody>
-          <a:bodyPr wrap="square" lIns="0" tIns="0" rIns="0" bIns="0" rtlCol="0" anchor="t"/>
-          <a:lstStyle/>
-          <a:p>
-            <a:pPr algn="l" indent="0" marL="0">
-              <a:lnSpc>
-                <a:spcPts val="1375"/>
-              </a:lnSpc>
-              <a:spcBef>
-                <a:spcPts val="500"/>
-              </a:spcBef>
-              <a:buNone/>
-            </a:pPr>
-            <a:r>
-              <a:rPr lang="en-US" sz="1100" b="1" dirty="0">
-                <a:solidFill>
-                  <a:srgbClr val="0B5E5C"/>
-                </a:solidFill>
-                <a:latin typeface="Arial" pitchFamily="34" charset="0"/>
-                <a:ea typeface="Arial" pitchFamily="34" charset="-122"/>
-                <a:cs typeface="Arial" pitchFamily="34" charset="-120"/>
-              </a:rPr>
-              <a:t>An toàn không nhường xác suất</a:t>
-            </a:r>
-            <a:endParaRPr lang="en-US" sz="1100" dirty="0"/>
-          </a:p>
-        </p:txBody>
-      </p:sp>
-      <p:sp>
-        <p:nvSpPr>
-          <p:cNvPr id="11" name="Text 9"/>
-          <p:cNvSpPr/>
-          <p:nvPr/>
-        </p:nvSpPr>
-        <p:spPr>
-          <a:xfrm>
-            <a:off x="542925" y="1983730"/>
-            <a:ext cx="1255121" cy="297061"/>
-          </a:xfrm>
-          <a:prstGeom prst="rect">
-            <a:avLst/>
-          </a:prstGeom>
-          <a:noFill/>
-          <a:ln/>
-        </p:spPr>
-        <p:txBody>
-          <a:bodyPr wrap="square" lIns="0" tIns="0" rIns="0" bIns="0" rtlCol="0" anchor="t"/>
-          <a:lstStyle/>
-          <a:p>
-            <a:pPr algn="l" indent="0" marL="0">
-              <a:lnSpc>
-                <a:spcPts val="1170"/>
-              </a:lnSpc>
-              <a:spcBef>
-                <a:spcPts val="500"/>
-              </a:spcBef>
-              <a:buNone/>
-            </a:pPr>
-            <a:r>
-              <a:rPr lang="en-US" sz="900" dirty="0">
-                <a:solidFill>
-                  <a:srgbClr val="5C7470"/>
-                </a:solidFill>
-                <a:latin typeface="Arial" pitchFamily="34" charset="0"/>
-                <a:ea typeface="Arial" pitchFamily="34" charset="-122"/>
-                <a:cs typeface="Arial" pitchFamily="34" charset="-120"/>
-              </a:rPr>
-              <a:t>Rule safety ép P5 dù model nghĩ khác.</a:t>
-            </a:r>
-            <a:endParaRPr lang="en-US" sz="900" dirty="0"/>
-          </a:p>
-        </p:txBody>
-      </p:sp>
-      <p:sp>
-        <p:nvSpPr>
-          <p:cNvPr id="12" name="Text 10"/>
-          <p:cNvSpPr/>
-          <p:nvPr/>
-        </p:nvSpPr>
-        <p:spPr>
-          <a:xfrm>
-            <a:off x="2087761" y="1069628"/>
-            <a:ext cx="1554510" cy="2686050"/>
-          </a:xfrm>
-          <a:prstGeom prst="roundRect">
-            <a:avLst>
-              <a:gd name="adj" fmla="val 8170"/>
-            </a:avLst>
-          </a:prstGeom>
-          <a:solidFill>
-            <a:srgbClr val="FFFFFF"/>
-          </a:solidFill>
-          <a:ln/>
+          <a:effectLst>
+            <a:outerShdw sx="100000" sy="100000" kx="0" ky="0" algn="bl" rotWithShape="0" blurRad="133350" dist="47625" dir="3180000">
+              <a:srgbClr val="0b5e5c">
+                <a:alpha val="22000"/>
+              </a:srgbClr>
+            </a:outerShdw>
+          </a:effectLst>
         </p:spPr>
         <p:txBody>
           <a:bodyPr wrap="square" rtlCol="0" anchor="ctr"/>
@@ -4287,1189 +4641,33 @@
           </a:p>
         </p:txBody>
       </p:sp>
-      <p:sp>
-        <p:nvSpPr>
-          <p:cNvPr id="13" name="Shape 11"/>
-          <p:cNvSpPr/>
-          <p:nvPr/>
-        </p:nvSpPr>
-        <p:spPr>
-          <a:xfrm>
-            <a:off x="2087761" y="1093440"/>
-            <a:ext cx="1554510" cy="0"/>
-          </a:xfrm>
-          <a:prstGeom prst="line">
-            <a:avLst/>
-          </a:prstGeom>
-          <a:noFill/>
-          <a:ln w="47625">
-            <a:solidFill>
-              <a:srgbClr val="0E8C84"/>
-            </a:solidFill>
-            <a:prstDash val="solid"/>
-          </a:ln>
-        </p:spPr>
-      </p:sp>
-      <p:sp>
-        <p:nvSpPr>
-          <p:cNvPr id="14" name="Shape 12"/>
-          <p:cNvSpPr/>
-          <p:nvPr/>
-        </p:nvSpPr>
-        <p:spPr>
-          <a:xfrm>
-            <a:off x="3637508" y="1069628"/>
-            <a:ext cx="0" cy="2686050"/>
-          </a:xfrm>
-          <a:prstGeom prst="line">
-            <a:avLst/>
-          </a:prstGeom>
-          <a:noFill/>
-          <a:ln w="9525">
-            <a:solidFill>
-              <a:srgbClr val="D9E8E4"/>
-            </a:solidFill>
-            <a:prstDash val="solid"/>
-          </a:ln>
-        </p:spPr>
-      </p:sp>
-      <p:sp>
-        <p:nvSpPr>
-          <p:cNvPr id="15" name="Shape 13"/>
-          <p:cNvSpPr/>
-          <p:nvPr/>
-        </p:nvSpPr>
-        <p:spPr>
-          <a:xfrm>
-            <a:off x="2087761" y="3750915"/>
-            <a:ext cx="1554510" cy="0"/>
-          </a:xfrm>
-          <a:prstGeom prst="line">
-            <a:avLst/>
-          </a:prstGeom>
-          <a:noFill/>
-          <a:ln w="9525">
-            <a:solidFill>
-              <a:srgbClr val="D9E8E4"/>
-            </a:solidFill>
-            <a:prstDash val="solid"/>
-          </a:ln>
-        </p:spPr>
-      </p:sp>
-      <p:sp>
-        <p:nvSpPr>
-          <p:cNvPr id="16" name="Shape 14"/>
-          <p:cNvSpPr/>
-          <p:nvPr/>
-        </p:nvSpPr>
-        <p:spPr>
-          <a:xfrm>
-            <a:off x="2092523" y="1069628"/>
-            <a:ext cx="0" cy="2686050"/>
-          </a:xfrm>
-          <a:prstGeom prst="line">
-            <a:avLst/>
-          </a:prstGeom>
-          <a:noFill/>
-          <a:ln w="9525">
-            <a:solidFill>
-              <a:srgbClr val="D9E8E4"/>
-            </a:solidFill>
-            <a:prstDash val="solid"/>
-          </a:ln>
-        </p:spPr>
-      </p:sp>
-      <p:sp>
-        <p:nvSpPr>
-          <p:cNvPr id="17" name="Text 15"/>
-          <p:cNvSpPr/>
-          <p:nvPr/>
-        </p:nvSpPr>
-        <p:spPr>
-          <a:xfrm>
-            <a:off x="2249686" y="1269653"/>
-            <a:ext cx="1255273" cy="238125"/>
-          </a:xfrm>
-          <a:prstGeom prst="rect">
-            <a:avLst/>
-          </a:prstGeom>
-          <a:noFill/>
-          <a:ln/>
-        </p:spPr>
-        <p:txBody>
-          <a:bodyPr wrap="square" lIns="0" tIns="0" rIns="0" bIns="0" rtlCol="0" anchor="t"/>
-          <a:lstStyle/>
-          <a:p>
-            <a:pPr algn="l" indent="0" marL="0">
-              <a:buNone/>
-            </a:pPr>
-            <a:r>
-              <a:rPr lang="en-US" sz="1600" b="1" dirty="0">
-                <a:solidFill>
-                  <a:srgbClr val="34D399"/>
-                </a:solidFill>
-                <a:latin typeface="Arial" pitchFamily="34" charset="0"/>
-                <a:ea typeface="Arial" pitchFamily="34" charset="-122"/>
-                <a:cs typeface="Arial" pitchFamily="34" charset="-120"/>
-              </a:rPr>
-              <a:t>02</a:t>
-            </a:r>
-            <a:endParaRPr lang="en-US" sz="1600" dirty="0"/>
-          </a:p>
-        </p:txBody>
-      </p:sp>
-      <p:sp>
-        <p:nvSpPr>
-          <p:cNvPr id="18" name="Text 16"/>
-          <p:cNvSpPr/>
-          <p:nvPr/>
-        </p:nvSpPr>
-        <p:spPr>
-          <a:xfrm>
-            <a:off x="2249686" y="1571179"/>
-            <a:ext cx="1255273" cy="349151"/>
-          </a:xfrm>
-          <a:prstGeom prst="rect">
-            <a:avLst/>
-          </a:prstGeom>
-          <a:noFill/>
-          <a:ln/>
-        </p:spPr>
-        <p:txBody>
-          <a:bodyPr wrap="square" lIns="0" tIns="0" rIns="0" bIns="0" rtlCol="0" anchor="t"/>
-          <a:lstStyle/>
-          <a:p>
-            <a:pPr algn="l" indent="0" marL="0">
-              <a:lnSpc>
-                <a:spcPts val="1375"/>
-              </a:lnSpc>
-              <a:spcBef>
-                <a:spcPts val="500"/>
-              </a:spcBef>
-              <a:buNone/>
-            </a:pPr>
-            <a:r>
-              <a:rPr lang="en-US" sz="1100" b="1" dirty="0">
-                <a:solidFill>
-                  <a:srgbClr val="0B5E5C"/>
-                </a:solidFill>
-                <a:latin typeface="Arial" pitchFamily="34" charset="0"/>
-                <a:ea typeface="Arial" pitchFamily="34" charset="-122"/>
-                <a:cs typeface="Arial" pitchFamily="34" charset="-120"/>
-              </a:rPr>
-              <a:t>Human-in-the-loop</a:t>
-            </a:r>
-            <a:endParaRPr lang="en-US" sz="1100" dirty="0"/>
-          </a:p>
-        </p:txBody>
-      </p:sp>
-      <p:sp>
-        <p:nvSpPr>
-          <p:cNvPr id="19" name="Text 17"/>
-          <p:cNvSpPr/>
-          <p:nvPr/>
-        </p:nvSpPr>
-        <p:spPr>
-          <a:xfrm>
-            <a:off x="2249686" y="1983730"/>
-            <a:ext cx="1255273" cy="445591"/>
-          </a:xfrm>
-          <a:prstGeom prst="rect">
-            <a:avLst/>
-          </a:prstGeom>
-          <a:noFill/>
-          <a:ln/>
-        </p:spPr>
-        <p:txBody>
-          <a:bodyPr wrap="square" lIns="0" tIns="0" rIns="0" bIns="0" rtlCol="0" anchor="t"/>
-          <a:lstStyle/>
-          <a:p>
-            <a:pPr algn="l" indent="0" marL="0">
-              <a:lnSpc>
-                <a:spcPts val="1170"/>
-              </a:lnSpc>
-              <a:spcBef>
-                <a:spcPts val="500"/>
-              </a:spcBef>
-              <a:buNone/>
-            </a:pPr>
-            <a:r>
-              <a:rPr lang="en-US" sz="900" dirty="0">
-                <a:solidFill>
-                  <a:srgbClr val="5C7470"/>
-                </a:solidFill>
-                <a:latin typeface="Arial" pitchFamily="34" charset="0"/>
-                <a:ea typeface="Arial" pitchFamily="34" charset="-122"/>
-                <a:cs typeface="Arial" pitchFamily="34" charset="-120"/>
-              </a:rPr>
-              <a:t>Máy đề xuất, con người quyết &amp; chịu trách nhiệm.</a:t>
-            </a:r>
-            <a:endParaRPr lang="en-US" sz="900" dirty="0"/>
-          </a:p>
-        </p:txBody>
-      </p:sp>
-      <p:sp>
-        <p:nvSpPr>
-          <p:cNvPr id="20" name="Text 18"/>
-          <p:cNvSpPr/>
-          <p:nvPr/>
-        </p:nvSpPr>
-        <p:spPr>
-          <a:xfrm>
-            <a:off x="3794671" y="1069628"/>
-            <a:ext cx="1554510" cy="2686050"/>
-          </a:xfrm>
-          <a:prstGeom prst="roundRect">
-            <a:avLst>
-              <a:gd name="adj" fmla="val 8170"/>
-            </a:avLst>
-          </a:prstGeom>
-          <a:solidFill>
-            <a:srgbClr val="FFFFFF"/>
-          </a:solidFill>
-          <a:ln/>
-        </p:spPr>
-        <p:txBody>
-          <a:bodyPr wrap="square" rtlCol="0" anchor="ctr"/>
-          <a:lstStyle/>
-          <a:p>
-            <a:pPr indent="0" marL="0">
-              <a:buNone/>
-            </a:pPr>
-            <a:endParaRPr lang="en-US" dirty="0"/>
-          </a:p>
-        </p:txBody>
-      </p:sp>
-      <p:sp>
-        <p:nvSpPr>
-          <p:cNvPr id="21" name="Shape 19"/>
-          <p:cNvSpPr/>
-          <p:nvPr/>
-        </p:nvSpPr>
-        <p:spPr>
-          <a:xfrm>
-            <a:off x="3794671" y="1093440"/>
-            <a:ext cx="1554510" cy="0"/>
-          </a:xfrm>
-          <a:prstGeom prst="line">
-            <a:avLst/>
-          </a:prstGeom>
-          <a:noFill/>
-          <a:ln w="47625">
-            <a:solidFill>
-              <a:srgbClr val="0E8C84"/>
-            </a:solidFill>
-            <a:prstDash val="solid"/>
-          </a:ln>
-        </p:spPr>
-      </p:sp>
-      <p:sp>
-        <p:nvSpPr>
-          <p:cNvPr id="22" name="Shape 20"/>
-          <p:cNvSpPr/>
-          <p:nvPr/>
-        </p:nvSpPr>
-        <p:spPr>
-          <a:xfrm>
-            <a:off x="5344418" y="1069628"/>
-            <a:ext cx="0" cy="2686050"/>
-          </a:xfrm>
-          <a:prstGeom prst="line">
-            <a:avLst/>
-          </a:prstGeom>
-          <a:noFill/>
-          <a:ln w="9525">
-            <a:solidFill>
-              <a:srgbClr val="D9E8E4"/>
-            </a:solidFill>
-            <a:prstDash val="solid"/>
-          </a:ln>
-        </p:spPr>
-      </p:sp>
-      <p:sp>
-        <p:nvSpPr>
-          <p:cNvPr id="23" name="Shape 21"/>
-          <p:cNvSpPr/>
-          <p:nvPr/>
-        </p:nvSpPr>
-        <p:spPr>
-          <a:xfrm>
-            <a:off x="3794671" y="3750915"/>
-            <a:ext cx="1554510" cy="0"/>
-          </a:xfrm>
-          <a:prstGeom prst="line">
-            <a:avLst/>
-          </a:prstGeom>
-          <a:noFill/>
-          <a:ln w="9525">
-            <a:solidFill>
-              <a:srgbClr val="D9E8E4"/>
-            </a:solidFill>
-            <a:prstDash val="solid"/>
-          </a:ln>
-        </p:spPr>
-      </p:sp>
-      <p:sp>
-        <p:nvSpPr>
-          <p:cNvPr id="24" name="Shape 22"/>
-          <p:cNvSpPr/>
-          <p:nvPr/>
-        </p:nvSpPr>
-        <p:spPr>
-          <a:xfrm>
-            <a:off x="3799433" y="1069628"/>
-            <a:ext cx="0" cy="2686050"/>
-          </a:xfrm>
-          <a:prstGeom prst="line">
-            <a:avLst/>
-          </a:prstGeom>
-          <a:noFill/>
-          <a:ln w="9525">
-            <a:solidFill>
-              <a:srgbClr val="D9E8E4"/>
-            </a:solidFill>
-            <a:prstDash val="solid"/>
-          </a:ln>
-        </p:spPr>
-      </p:sp>
-      <p:sp>
-        <p:nvSpPr>
-          <p:cNvPr id="25" name="Text 23"/>
-          <p:cNvSpPr/>
-          <p:nvPr/>
-        </p:nvSpPr>
-        <p:spPr>
-          <a:xfrm>
-            <a:off x="3956596" y="1269653"/>
-            <a:ext cx="1255273" cy="238125"/>
-          </a:xfrm>
-          <a:prstGeom prst="rect">
-            <a:avLst/>
-          </a:prstGeom>
-          <a:noFill/>
-          <a:ln/>
-        </p:spPr>
-        <p:txBody>
-          <a:bodyPr wrap="square" lIns="0" tIns="0" rIns="0" bIns="0" rtlCol="0" anchor="t"/>
-          <a:lstStyle/>
-          <a:p>
-            <a:pPr algn="l" indent="0" marL="0">
-              <a:buNone/>
-            </a:pPr>
-            <a:r>
-              <a:rPr lang="en-US" sz="1600" b="1" dirty="0">
-                <a:solidFill>
-                  <a:srgbClr val="34D399"/>
-                </a:solidFill>
-                <a:latin typeface="Arial" pitchFamily="34" charset="0"/>
-                <a:ea typeface="Arial" pitchFamily="34" charset="-122"/>
-                <a:cs typeface="Arial" pitchFamily="34" charset="-120"/>
-              </a:rPr>
-              <a:t>03</a:t>
-            </a:r>
-            <a:endParaRPr lang="en-US" sz="1600" dirty="0"/>
-          </a:p>
-        </p:txBody>
-      </p:sp>
-      <p:sp>
-        <p:nvSpPr>
-          <p:cNvPr id="26" name="Text 24"/>
-          <p:cNvSpPr/>
-          <p:nvPr/>
-        </p:nvSpPr>
-        <p:spPr>
-          <a:xfrm>
-            <a:off x="3956596" y="1571179"/>
-            <a:ext cx="1255273" cy="349151"/>
-          </a:xfrm>
-          <a:prstGeom prst="rect">
-            <a:avLst/>
-          </a:prstGeom>
-          <a:noFill/>
-          <a:ln/>
-        </p:spPr>
-        <p:txBody>
-          <a:bodyPr wrap="square" lIns="0" tIns="0" rIns="0" bIns="0" rtlCol="0" anchor="t"/>
-          <a:lstStyle/>
-          <a:p>
-            <a:pPr algn="l" indent="0" marL="0">
-              <a:lnSpc>
-                <a:spcPts val="1375"/>
-              </a:lnSpc>
-              <a:spcBef>
-                <a:spcPts val="500"/>
-              </a:spcBef>
-              <a:buNone/>
-            </a:pPr>
-            <a:r>
-              <a:rPr lang="en-US" sz="1100" b="1" dirty="0">
-                <a:solidFill>
-                  <a:srgbClr val="0B5E5C"/>
-                </a:solidFill>
-                <a:latin typeface="Arial" pitchFamily="34" charset="0"/>
-                <a:ea typeface="Arial" pitchFamily="34" charset="-122"/>
-                <a:cs typeface="Arial" pitchFamily="34" charset="-120"/>
-              </a:rPr>
-              <a:t>Phân quyền tự động</a:t>
-            </a:r>
-            <a:endParaRPr lang="en-US" sz="1100" dirty="0"/>
-          </a:p>
-        </p:txBody>
-      </p:sp>
-      <p:sp>
-        <p:nvSpPr>
-          <p:cNvPr id="27" name="Text 25"/>
-          <p:cNvSpPr/>
-          <p:nvPr/>
-        </p:nvSpPr>
-        <p:spPr>
-          <a:xfrm>
-            <a:off x="3956596" y="1983730"/>
-            <a:ext cx="1255273" cy="297061"/>
-          </a:xfrm>
-          <a:prstGeom prst="rect">
-            <a:avLst/>
-          </a:prstGeom>
-          <a:noFill/>
-          <a:ln/>
-        </p:spPr>
-        <p:txBody>
-          <a:bodyPr wrap="square" lIns="0" tIns="0" rIns="0" bIns="0" rtlCol="0" anchor="t"/>
-          <a:lstStyle/>
-          <a:p>
-            <a:pPr algn="l" indent="0" marL="0">
-              <a:lnSpc>
-                <a:spcPts val="1170"/>
-              </a:lnSpc>
-              <a:spcBef>
-                <a:spcPts val="500"/>
-              </a:spcBef>
-              <a:buNone/>
-            </a:pPr>
-            <a:r>
-              <a:rPr lang="en-US" sz="900" dirty="0">
-                <a:solidFill>
-                  <a:srgbClr val="5C7470"/>
-                </a:solidFill>
-                <a:latin typeface="Arial" pitchFamily="34" charset="0"/>
-                <a:ea typeface="Arial" pitchFamily="34" charset="-122"/>
-                <a:cs typeface="Arial" pitchFamily="34" charset="-120"/>
-              </a:rPr>
-              <a:t>RBAC 4 vai trò, dữ liệu lọc theo role qua RLS.</a:t>
-            </a:r>
-            <a:endParaRPr lang="en-US" sz="900" dirty="0"/>
-          </a:p>
-        </p:txBody>
-      </p:sp>
-      <p:sp>
-        <p:nvSpPr>
-          <p:cNvPr id="28" name="Text 26"/>
-          <p:cNvSpPr/>
-          <p:nvPr/>
-        </p:nvSpPr>
-        <p:spPr>
-          <a:xfrm>
-            <a:off x="5501580" y="1069628"/>
-            <a:ext cx="1554510" cy="2686050"/>
-          </a:xfrm>
-          <a:prstGeom prst="roundRect">
-            <a:avLst>
-              <a:gd name="adj" fmla="val 8170"/>
-            </a:avLst>
-          </a:prstGeom>
-          <a:solidFill>
-            <a:srgbClr val="FFFFFF"/>
-          </a:solidFill>
-          <a:ln/>
-        </p:spPr>
-        <p:txBody>
-          <a:bodyPr wrap="square" rtlCol="0" anchor="ctr"/>
-          <a:lstStyle/>
-          <a:p>
-            <a:pPr indent="0" marL="0">
-              <a:buNone/>
-            </a:pPr>
-            <a:endParaRPr lang="en-US" dirty="0"/>
-          </a:p>
-        </p:txBody>
-      </p:sp>
-      <p:sp>
-        <p:nvSpPr>
-          <p:cNvPr id="29" name="Shape 27"/>
-          <p:cNvSpPr/>
-          <p:nvPr/>
-        </p:nvSpPr>
-        <p:spPr>
-          <a:xfrm>
-            <a:off x="5501580" y="1093440"/>
-            <a:ext cx="1554510" cy="0"/>
-          </a:xfrm>
-          <a:prstGeom prst="line">
-            <a:avLst/>
-          </a:prstGeom>
-          <a:noFill/>
-          <a:ln w="47625">
-            <a:solidFill>
-              <a:srgbClr val="0E8C84"/>
-            </a:solidFill>
-            <a:prstDash val="solid"/>
-          </a:ln>
-        </p:spPr>
-      </p:sp>
-      <p:sp>
-        <p:nvSpPr>
-          <p:cNvPr id="30" name="Shape 28"/>
-          <p:cNvSpPr/>
-          <p:nvPr/>
-        </p:nvSpPr>
-        <p:spPr>
-          <a:xfrm>
-            <a:off x="7051328" y="1069628"/>
-            <a:ext cx="0" cy="2686050"/>
-          </a:xfrm>
-          <a:prstGeom prst="line">
-            <a:avLst/>
-          </a:prstGeom>
-          <a:noFill/>
-          <a:ln w="9525">
-            <a:solidFill>
-              <a:srgbClr val="D9E8E4"/>
-            </a:solidFill>
-            <a:prstDash val="solid"/>
-          </a:ln>
-        </p:spPr>
-      </p:sp>
-      <p:sp>
-        <p:nvSpPr>
-          <p:cNvPr id="31" name="Shape 29"/>
-          <p:cNvSpPr/>
-          <p:nvPr/>
-        </p:nvSpPr>
-        <p:spPr>
-          <a:xfrm>
-            <a:off x="5501580" y="3750915"/>
-            <a:ext cx="1554510" cy="0"/>
-          </a:xfrm>
-          <a:prstGeom prst="line">
-            <a:avLst/>
-          </a:prstGeom>
-          <a:noFill/>
-          <a:ln w="9525">
-            <a:solidFill>
-              <a:srgbClr val="D9E8E4"/>
-            </a:solidFill>
-            <a:prstDash val="solid"/>
-          </a:ln>
-        </p:spPr>
-      </p:sp>
-      <p:sp>
-        <p:nvSpPr>
-          <p:cNvPr id="32" name="Shape 30"/>
-          <p:cNvSpPr/>
-          <p:nvPr/>
-        </p:nvSpPr>
-        <p:spPr>
-          <a:xfrm>
-            <a:off x="5506343" y="1069628"/>
-            <a:ext cx="0" cy="2686050"/>
-          </a:xfrm>
-          <a:prstGeom prst="line">
-            <a:avLst/>
-          </a:prstGeom>
-          <a:noFill/>
-          <a:ln w="9525">
-            <a:solidFill>
-              <a:srgbClr val="D9E8E4"/>
-            </a:solidFill>
-            <a:prstDash val="solid"/>
-          </a:ln>
-        </p:spPr>
-      </p:sp>
-      <p:sp>
-        <p:nvSpPr>
-          <p:cNvPr id="33" name="Text 31"/>
-          <p:cNvSpPr/>
-          <p:nvPr/>
-        </p:nvSpPr>
-        <p:spPr>
-          <a:xfrm>
-            <a:off x="5663505" y="1269653"/>
-            <a:ext cx="1255273" cy="238125"/>
-          </a:xfrm>
-          <a:prstGeom prst="rect">
-            <a:avLst/>
-          </a:prstGeom>
-          <a:noFill/>
-          <a:ln/>
-        </p:spPr>
-        <p:txBody>
-          <a:bodyPr wrap="square" lIns="0" tIns="0" rIns="0" bIns="0" rtlCol="0" anchor="t"/>
-          <a:lstStyle/>
-          <a:p>
-            <a:pPr algn="l" indent="0" marL="0">
-              <a:buNone/>
-            </a:pPr>
-            <a:r>
-              <a:rPr lang="en-US" sz="1600" b="1" dirty="0">
-                <a:solidFill>
-                  <a:srgbClr val="34D399"/>
-                </a:solidFill>
-                <a:latin typeface="Arial" pitchFamily="34" charset="0"/>
-                <a:ea typeface="Arial" pitchFamily="34" charset="-122"/>
-                <a:cs typeface="Arial" pitchFamily="34" charset="-120"/>
-              </a:rPr>
-              <a:t>04</a:t>
-            </a:r>
-            <a:endParaRPr lang="en-US" sz="1600" dirty="0"/>
-          </a:p>
-        </p:txBody>
-      </p:sp>
-      <p:sp>
-        <p:nvSpPr>
-          <p:cNvPr id="34" name="Text 32"/>
-          <p:cNvSpPr/>
-          <p:nvPr/>
-        </p:nvSpPr>
-        <p:spPr>
-          <a:xfrm>
-            <a:off x="5663505" y="1571179"/>
-            <a:ext cx="1255273" cy="349151"/>
-          </a:xfrm>
-          <a:prstGeom prst="rect">
-            <a:avLst/>
-          </a:prstGeom>
-          <a:noFill/>
-          <a:ln/>
-        </p:spPr>
-        <p:txBody>
-          <a:bodyPr wrap="square" lIns="0" tIns="0" rIns="0" bIns="0" rtlCol="0" anchor="t"/>
-          <a:lstStyle/>
-          <a:p>
-            <a:pPr algn="l" indent="0" marL="0">
-              <a:lnSpc>
-                <a:spcPts val="1375"/>
-              </a:lnSpc>
-              <a:spcBef>
-                <a:spcPts val="500"/>
-              </a:spcBef>
-              <a:buNone/>
-            </a:pPr>
-            <a:r>
-              <a:rPr lang="en-US" sz="1100" b="1" dirty="0">
-                <a:solidFill>
-                  <a:srgbClr val="0B5E5C"/>
-                </a:solidFill>
-                <a:latin typeface="Arial" pitchFamily="34" charset="0"/>
-                <a:ea typeface="Arial" pitchFamily="34" charset="-122"/>
-                <a:cs typeface="Arial" pitchFamily="34" charset="-120"/>
-              </a:rPr>
-              <a:t>Khép kín phản hồi → hành động</a:t>
-            </a:r>
-            <a:endParaRPr lang="en-US" sz="1100" dirty="0"/>
-          </a:p>
-        </p:txBody>
-      </p:sp>
-      <p:sp>
-        <p:nvSpPr>
-          <p:cNvPr id="35" name="Text 33"/>
-          <p:cNvSpPr/>
-          <p:nvPr/>
-        </p:nvSpPr>
-        <p:spPr>
-          <a:xfrm>
-            <a:off x="5663505" y="1983730"/>
-            <a:ext cx="1255273" cy="297061"/>
-          </a:xfrm>
-          <a:prstGeom prst="rect">
-            <a:avLst/>
-          </a:prstGeom>
-          <a:noFill/>
-          <a:ln/>
-        </p:spPr>
-        <p:txBody>
-          <a:bodyPr wrap="square" lIns="0" tIns="0" rIns="0" bIns="0" rtlCol="0" anchor="t"/>
-          <a:lstStyle/>
-          <a:p>
-            <a:pPr algn="l" indent="0" marL="0">
-              <a:lnSpc>
-                <a:spcPts val="1170"/>
-              </a:lnSpc>
-              <a:spcBef>
-                <a:spcPts val="500"/>
-              </a:spcBef>
-              <a:buNone/>
-            </a:pPr>
-            <a:r>
-              <a:rPr lang="en-US" sz="900" dirty="0">
-                <a:solidFill>
-                  <a:srgbClr val="5C7470"/>
-                </a:solidFill>
-                <a:latin typeface="Arial" pitchFamily="34" charset="0"/>
-                <a:ea typeface="Arial" pitchFamily="34" charset="-122"/>
-                <a:cs typeface="Arial" pitchFamily="34" charset="-120"/>
-              </a:rPr>
-              <a:t>Mọi phân tích phải dẫn tới việc được giao.</a:t>
-            </a:r>
-            <a:endParaRPr lang="en-US" sz="900" dirty="0"/>
-          </a:p>
-        </p:txBody>
-      </p:sp>
-      <p:sp>
-        <p:nvSpPr>
-          <p:cNvPr id="36" name="Text 34"/>
-          <p:cNvSpPr/>
-          <p:nvPr/>
-        </p:nvSpPr>
-        <p:spPr>
-          <a:xfrm>
-            <a:off x="7208490" y="1069628"/>
-            <a:ext cx="1554510" cy="2686050"/>
-          </a:xfrm>
-          <a:prstGeom prst="roundRect">
-            <a:avLst>
-              <a:gd name="adj" fmla="val 8170"/>
-            </a:avLst>
-          </a:prstGeom>
-          <a:solidFill>
-            <a:srgbClr val="FFFFFF"/>
-          </a:solidFill>
-          <a:ln/>
-        </p:spPr>
-        <p:txBody>
-          <a:bodyPr wrap="square" rtlCol="0" anchor="ctr"/>
-          <a:lstStyle/>
-          <a:p>
-            <a:pPr indent="0" marL="0">
-              <a:buNone/>
-            </a:pPr>
-            <a:endParaRPr lang="en-US" dirty="0"/>
-          </a:p>
-        </p:txBody>
-      </p:sp>
-      <p:sp>
-        <p:nvSpPr>
-          <p:cNvPr id="37" name="Shape 35"/>
-          <p:cNvSpPr/>
-          <p:nvPr/>
-        </p:nvSpPr>
-        <p:spPr>
-          <a:xfrm>
-            <a:off x="7208490" y="1093440"/>
-            <a:ext cx="1554510" cy="0"/>
-          </a:xfrm>
-          <a:prstGeom prst="line">
-            <a:avLst/>
-          </a:prstGeom>
-          <a:noFill/>
-          <a:ln w="47625">
-            <a:solidFill>
-              <a:srgbClr val="0E8C84"/>
-            </a:solidFill>
-            <a:prstDash val="solid"/>
-          </a:ln>
-        </p:spPr>
-      </p:sp>
-      <p:sp>
-        <p:nvSpPr>
-          <p:cNvPr id="38" name="Shape 36"/>
-          <p:cNvSpPr/>
-          <p:nvPr/>
-        </p:nvSpPr>
-        <p:spPr>
-          <a:xfrm>
-            <a:off x="8758238" y="1069628"/>
-            <a:ext cx="0" cy="2686050"/>
-          </a:xfrm>
-          <a:prstGeom prst="line">
-            <a:avLst/>
-          </a:prstGeom>
-          <a:noFill/>
-          <a:ln w="9525">
-            <a:solidFill>
-              <a:srgbClr val="D9E8E4"/>
-            </a:solidFill>
-            <a:prstDash val="solid"/>
-          </a:ln>
-        </p:spPr>
-      </p:sp>
-      <p:sp>
-        <p:nvSpPr>
-          <p:cNvPr id="39" name="Shape 37"/>
-          <p:cNvSpPr/>
-          <p:nvPr/>
-        </p:nvSpPr>
-        <p:spPr>
-          <a:xfrm>
-            <a:off x="7208490" y="3750915"/>
-            <a:ext cx="1554510" cy="0"/>
-          </a:xfrm>
-          <a:prstGeom prst="line">
-            <a:avLst/>
-          </a:prstGeom>
-          <a:noFill/>
-          <a:ln w="9525">
-            <a:solidFill>
-              <a:srgbClr val="D9E8E4"/>
-            </a:solidFill>
-            <a:prstDash val="solid"/>
-          </a:ln>
-        </p:spPr>
-      </p:sp>
-      <p:sp>
-        <p:nvSpPr>
-          <p:cNvPr id="40" name="Shape 38"/>
-          <p:cNvSpPr/>
-          <p:nvPr/>
-        </p:nvSpPr>
-        <p:spPr>
-          <a:xfrm>
-            <a:off x="7213253" y="1069628"/>
-            <a:ext cx="0" cy="2686050"/>
-          </a:xfrm>
-          <a:prstGeom prst="line">
-            <a:avLst/>
-          </a:prstGeom>
-          <a:noFill/>
-          <a:ln w="9525">
-            <a:solidFill>
-              <a:srgbClr val="D9E8E4"/>
-            </a:solidFill>
-            <a:prstDash val="solid"/>
-          </a:ln>
-        </p:spPr>
-      </p:sp>
-      <p:sp>
-        <p:nvSpPr>
-          <p:cNvPr id="41" name="Text 39"/>
-          <p:cNvSpPr/>
-          <p:nvPr/>
-        </p:nvSpPr>
-        <p:spPr>
-          <a:xfrm>
-            <a:off x="7370415" y="1269653"/>
-            <a:ext cx="1255273" cy="238125"/>
-          </a:xfrm>
-          <a:prstGeom prst="rect">
-            <a:avLst/>
-          </a:prstGeom>
-          <a:noFill/>
-          <a:ln/>
-        </p:spPr>
-        <p:txBody>
-          <a:bodyPr wrap="square" lIns="0" tIns="0" rIns="0" bIns="0" rtlCol="0" anchor="t"/>
-          <a:lstStyle/>
-          <a:p>
-            <a:pPr algn="l" indent="0" marL="0">
-              <a:buNone/>
-            </a:pPr>
-            <a:r>
-              <a:rPr lang="en-US" sz="1600" b="1" dirty="0">
-                <a:solidFill>
-                  <a:srgbClr val="34D399"/>
-                </a:solidFill>
-                <a:latin typeface="Arial" pitchFamily="34" charset="0"/>
-                <a:ea typeface="Arial" pitchFamily="34" charset="-122"/>
-                <a:cs typeface="Arial" pitchFamily="34" charset="-120"/>
-              </a:rPr>
-              <a:t>05</a:t>
-            </a:r>
-            <a:endParaRPr lang="en-US" sz="1600" dirty="0"/>
-          </a:p>
-        </p:txBody>
-      </p:sp>
-      <p:sp>
-        <p:nvSpPr>
-          <p:cNvPr id="42" name="Text 40"/>
-          <p:cNvSpPr/>
-          <p:nvPr/>
-        </p:nvSpPr>
-        <p:spPr>
-          <a:xfrm>
-            <a:off x="7370415" y="1571179"/>
-            <a:ext cx="1255273" cy="174575"/>
-          </a:xfrm>
-          <a:prstGeom prst="rect">
-            <a:avLst/>
-          </a:prstGeom>
-          <a:noFill/>
-          <a:ln/>
-        </p:spPr>
-        <p:txBody>
-          <a:bodyPr wrap="square" lIns="0" tIns="0" rIns="0" bIns="0" rtlCol="0" anchor="t"/>
-          <a:lstStyle/>
-          <a:p>
-            <a:pPr algn="l" indent="0" marL="0">
-              <a:lnSpc>
-                <a:spcPts val="1375"/>
-              </a:lnSpc>
-              <a:spcBef>
-                <a:spcPts val="500"/>
-              </a:spcBef>
-              <a:buNone/>
-            </a:pPr>
-            <a:r>
-              <a:rPr lang="en-US" sz="1100" b="1" dirty="0">
-                <a:solidFill>
-                  <a:srgbClr val="0B5E5C"/>
-                </a:solidFill>
-                <a:latin typeface="Arial" pitchFamily="34" charset="0"/>
-                <a:ea typeface="Arial" pitchFamily="34" charset="-122"/>
-                <a:cs typeface="Arial" pitchFamily="34" charset="-120"/>
-              </a:rPr>
-              <a:t>Realtime-first</a:t>
-            </a:r>
-            <a:endParaRPr lang="en-US" sz="1100" dirty="0"/>
-          </a:p>
-        </p:txBody>
-      </p:sp>
-      <p:sp>
-        <p:nvSpPr>
-          <p:cNvPr id="43" name="Text 41"/>
-          <p:cNvSpPr/>
-          <p:nvPr/>
-        </p:nvSpPr>
-        <p:spPr>
-          <a:xfrm>
-            <a:off x="7370415" y="1809155"/>
-            <a:ext cx="1255273" cy="445591"/>
-          </a:xfrm>
-          <a:prstGeom prst="rect">
-            <a:avLst/>
-          </a:prstGeom>
-          <a:noFill/>
-          <a:ln/>
-        </p:spPr>
-        <p:txBody>
-          <a:bodyPr wrap="square" lIns="0" tIns="0" rIns="0" bIns="0" rtlCol="0" anchor="t"/>
-          <a:lstStyle/>
-          <a:p>
-            <a:pPr algn="l" indent="0" marL="0">
-              <a:lnSpc>
-                <a:spcPts val="1170"/>
-              </a:lnSpc>
-              <a:spcBef>
-                <a:spcPts val="500"/>
-              </a:spcBef>
-              <a:buNone/>
-            </a:pPr>
-            <a:r>
-              <a:rPr lang="en-US" sz="900" dirty="0">
-                <a:solidFill>
-                  <a:srgbClr val="5C7470"/>
-                </a:solidFill>
-                <a:latin typeface="Arial" pitchFamily="34" charset="0"/>
-                <a:ea typeface="Arial" pitchFamily="34" charset="-122"/>
-                <a:cs typeface="Arial" pitchFamily="34" charset="-120"/>
-              </a:rPr>
-              <a:t>Thấy vấn đề khi nó đang xảy ra, không phải hôm sau.</a:t>
-            </a:r>
-            <a:endParaRPr lang="en-US" sz="900" dirty="0"/>
-          </a:p>
-        </p:txBody>
-      </p:sp>
-      <p:sp>
-        <p:nvSpPr>
-          <p:cNvPr id="44" name="Text 42"/>
-          <p:cNvSpPr/>
-          <p:nvPr/>
-        </p:nvSpPr>
-        <p:spPr>
-          <a:xfrm>
-            <a:off x="381000" y="3958828"/>
-            <a:ext cx="8382000" cy="714970"/>
-          </a:xfrm>
-          <a:prstGeom prst="roundRect">
-            <a:avLst>
-              <a:gd name="adj" fmla="val 17763"/>
-            </a:avLst>
-          </a:prstGeom>
-          <a:solidFill>
-            <a:srgbClr val="FFFFFF"/>
-          </a:solidFill>
-          <a:ln/>
-        </p:spPr>
-        <p:txBody>
-          <a:bodyPr wrap="square" rtlCol="0" anchor="ctr"/>
-          <a:lstStyle/>
-          <a:p>
-            <a:pPr indent="0" marL="0">
-              <a:buNone/>
-            </a:pPr>
-            <a:endParaRPr lang="en-US" dirty="0"/>
-          </a:p>
-        </p:txBody>
-      </p:sp>
-      <p:sp>
-        <p:nvSpPr>
-          <p:cNvPr id="45" name="Shape 43"/>
-          <p:cNvSpPr/>
-          <p:nvPr/>
-        </p:nvSpPr>
-        <p:spPr>
-          <a:xfrm>
-            <a:off x="381000" y="3963591"/>
-            <a:ext cx="8382000" cy="0"/>
-          </a:xfrm>
-          <a:prstGeom prst="line">
-            <a:avLst/>
-          </a:prstGeom>
-          <a:noFill/>
-          <a:ln w="9525">
-            <a:solidFill>
-              <a:srgbClr val="D9E8E4"/>
-            </a:solidFill>
-            <a:prstDash val="solid"/>
-          </a:ln>
-        </p:spPr>
-      </p:sp>
-      <p:sp>
-        <p:nvSpPr>
-          <p:cNvPr id="46" name="Shape 44"/>
-          <p:cNvSpPr/>
-          <p:nvPr/>
-        </p:nvSpPr>
-        <p:spPr>
-          <a:xfrm>
-            <a:off x="8758237" y="3958828"/>
-            <a:ext cx="0" cy="714970"/>
-          </a:xfrm>
-          <a:prstGeom prst="line">
-            <a:avLst/>
-          </a:prstGeom>
-          <a:noFill/>
-          <a:ln w="9525">
-            <a:solidFill>
-              <a:srgbClr val="D9E8E4"/>
-            </a:solidFill>
-            <a:prstDash val="solid"/>
-          </a:ln>
-        </p:spPr>
-      </p:sp>
-      <p:sp>
-        <p:nvSpPr>
-          <p:cNvPr id="47" name="Shape 45"/>
-          <p:cNvSpPr/>
-          <p:nvPr/>
-        </p:nvSpPr>
-        <p:spPr>
-          <a:xfrm>
-            <a:off x="381000" y="4669036"/>
-            <a:ext cx="8382000" cy="0"/>
-          </a:xfrm>
-          <a:prstGeom prst="line">
-            <a:avLst/>
-          </a:prstGeom>
-          <a:noFill/>
-          <a:ln w="9525">
-            <a:solidFill>
-              <a:srgbClr val="D9E8E4"/>
-            </a:solidFill>
-            <a:prstDash val="solid"/>
-          </a:ln>
-        </p:spPr>
-      </p:sp>
-      <p:sp>
-        <p:nvSpPr>
-          <p:cNvPr id="48" name="Shape 46"/>
-          <p:cNvSpPr/>
-          <p:nvPr/>
-        </p:nvSpPr>
-        <p:spPr>
-          <a:xfrm>
-            <a:off x="409575" y="3958828"/>
-            <a:ext cx="0" cy="714970"/>
-          </a:xfrm>
-          <a:prstGeom prst="line">
-            <a:avLst/>
-          </a:prstGeom>
-          <a:noFill/>
-          <a:ln w="57150">
-            <a:solidFill>
-              <a:srgbClr val="34D399"/>
-            </a:solidFill>
-            <a:prstDash val="solid"/>
-          </a:ln>
-        </p:spPr>
-      </p:sp>
-      <p:sp>
-        <p:nvSpPr>
-          <p:cNvPr id="49" name="Text 47"/>
-          <p:cNvSpPr/>
-          <p:nvPr/>
-        </p:nvSpPr>
-        <p:spPr>
-          <a:xfrm>
-            <a:off x="590550" y="4120753"/>
-            <a:ext cx="8170736" cy="391120"/>
-          </a:xfrm>
-          <a:prstGeom prst="rect">
-            <a:avLst/>
-          </a:prstGeom>
-          <a:noFill/>
-          <a:ln/>
-        </p:spPr>
-        <p:txBody>
-          <a:bodyPr wrap="square" lIns="0" tIns="0" rIns="0" bIns="0" rtlCol="0" anchor="t"/>
-          <a:lstStyle/>
-          <a:p>
-            <a:pPr algn="l" indent="0" marL="0">
-              <a:lnSpc>
-                <a:spcPts val="1540"/>
-              </a:lnSpc>
-              <a:buNone/>
-            </a:pPr>
-            <a:r>
-              <a:rPr lang="en-US" sz="1100" dirty="0">
-                <a:solidFill>
-                  <a:srgbClr val="0E2B29"/>
-                </a:solidFill>
-                <a:latin typeface="Arial" pitchFamily="34" charset="0"/>
-                <a:ea typeface="Arial" pitchFamily="34" charset="-122"/>
-                <a:cs typeface="Arial" pitchFamily="34" charset="-120"/>
-              </a:rPr>
-              <a:t>Sản phẩm không dừng ở "phân loại đúng" — nó được thiết kế để </a:t>
-            </a:r>
-            <a:pPr algn="l" indent="0" marL="0">
-              <a:lnSpc>
-                <a:spcPts val="1540"/>
-              </a:lnSpc>
-              <a:buNone/>
-            </a:pPr>
-            <a:r>
-              <a:rPr lang="en-US" sz="1100" b="1" dirty="0">
-                <a:solidFill>
-                  <a:srgbClr val="0E2B29"/>
-                </a:solidFill>
-                <a:latin typeface="Arial" pitchFamily="34" charset="0"/>
-                <a:ea typeface="Arial" pitchFamily="34" charset="-122"/>
-                <a:cs typeface="Arial" pitchFamily="34" charset="-120"/>
-              </a:rPr>
-              <a:t>rút ngắn khoảng cách giữa một lời phàn nàn và một hành động khắc phục</a:t>
-            </a:r>
-            <a:pPr algn="l" indent="0" marL="0">
-              <a:lnSpc>
-                <a:spcPts val="1540"/>
-              </a:lnSpc>
-              <a:buNone/>
-            </a:pPr>
-            <a:r>
-              <a:rPr lang="en-US" sz="1100" dirty="0">
-                <a:solidFill>
-                  <a:srgbClr val="0E2B29"/>
-                </a:solidFill>
-                <a:latin typeface="Arial" pitchFamily="34" charset="0"/>
-                <a:ea typeface="Arial" pitchFamily="34" charset="-122"/>
-                <a:cs typeface="Arial" pitchFamily="34" charset="-120"/>
-              </a:rPr>
-              <a:t>.</a:t>
-            </a:r>
-            <a:endParaRPr lang="en-US" sz="1100" dirty="0"/>
-          </a:p>
-        </p:txBody>
-      </p:sp>
-      <p:sp>
-        <p:nvSpPr>
-          <p:cNvPr id="50" name="Text 48"/>
+      <p:pic>
+        <p:nvPicPr>
+          <p:cNvPr id="6" name="Image 0" descr="/private/tmp/claude-501/-Users-kenz-de-projects-C2-App-116/3d8df5ac-6b2b-4cce-a997-fe0b4573b465/scratchpad/build/assets/staff.png">    </p:cNvPr>
+          <p:cNvPicPr>
+            <a:picLocks noChangeAspect="1"/>
+          </p:cNvPicPr>
+          <p:nvPr/>
+        </p:nvPicPr>
+        <p:blipFill>
+          <a:blip r:embed="rId1"/>
+          <a:stretch>
+            <a:fillRect/>
+          </a:stretch>
+        </p:blipFill>
+        <p:spPr>
+          <a:xfrm>
+            <a:off x="3705225" y="1091803"/>
+            <a:ext cx="4984849" cy="3116907"/>
+          </a:xfrm>
+          <a:prstGeom prst="rect">
+            <a:avLst/>
+          </a:prstGeom>
+        </p:spPr>
+      </p:pic>
+      <p:sp>
+        <p:nvSpPr>
+          <p:cNvPr id="7" name="Text 4"/>
           <p:cNvSpPr/>
           <p:nvPr/>
         </p:nvSpPr>
@@ -5550,7 +4748,7 @@
         <p:spPr>
           <a:xfrm>
             <a:off x="381000" y="330101"/>
-            <a:ext cx="8549640" cy="142875"/>
+            <a:ext cx="8549640" cy="200025"/>
           </a:xfrm>
           <a:prstGeom prst="rect">
             <a:avLst/>
@@ -5577,7 +4775,7 @@
                 <a:ea typeface="Arial" pitchFamily="34" charset="-122"/>
                 <a:cs typeface="Arial" pitchFamily="34" charset="-120"/>
               </a:rPr>
-              <a:t>KẾT QUẢ &amp; ROADMAP</a:t>
+              <a:t>CÁCH HOẠT ĐỘNG ⑥</a:t>
             </a:r>
             <a:endParaRPr lang="en-US" sz="1000" dirty="0"/>
           </a:p>
@@ -5591,7 +4789,7 @@
         </p:nvSpPr>
         <p:spPr>
           <a:xfrm>
-            <a:off x="381000" y="523726"/>
+            <a:off x="381000" y="580876"/>
             <a:ext cx="8549640" cy="342751"/>
           </a:xfrm>
           <a:prstGeom prst="rect">
@@ -5619,7 +4817,7 @@
                 <a:ea typeface="Arial" pitchFamily="34" charset="-122"/>
                 <a:cs typeface="Arial" pitchFamily="34" charset="-120"/>
               </a:rPr>
-              <a:t>Đã hoàn thiện vòng khép kín, sẵn sàng mở rộng</a:t>
+              <a:t>AI Chat + RAG Hybrid, phân quyền theo vai trò</a:t>
             </a:r>
             <a:endParaRPr lang="en-US" sz="2500" dirty="0"/>
           </a:p>
@@ -5633,7 +4831,7 @@
         </p:nvSpPr>
         <p:spPr>
           <a:xfrm>
-            <a:off x="381000" y="1095077"/>
+            <a:off x="381000" y="1152227"/>
             <a:ext cx="3048149" cy="1946672"/>
           </a:xfrm>
           <a:prstGeom prst="rect">
@@ -5657,15 +4855,15 @@
               <a:buChar char="•"/>
             </a:pPr>
             <a:r>
-              <a:rPr lang="en-US" sz="1150" b="1" dirty="0">
-                <a:solidFill>
-                  <a:srgbClr val="0E2B29"/>
-                </a:solidFill>
-                <a:latin typeface="Arial" pitchFamily="34" charset="0"/>
-                <a:ea typeface="Arial" pitchFamily="34" charset="-122"/>
-                <a:cs typeface="Arial" pitchFamily="34" charset="-120"/>
-              </a:rPr>
-              <a:t>Đã có:</a:t>
+              <a:rPr lang="en-US" sz="1150" dirty="0">
+                <a:solidFill>
+                  <a:srgbClr val="0E2B29"/>
+                </a:solidFill>
+                <a:latin typeface="Arial" pitchFamily="34" charset="0"/>
+                <a:ea typeface="Arial" pitchFamily="34" charset="-122"/>
+                <a:cs typeface="Arial" pitchFamily="34" charset="-120"/>
+              </a:rPr>
+              <a:t>Hybrid Search: </a:t>
             </a:r>
             <a:pPr algn="l" indent="0" marL="0">
               <a:lnSpc>
@@ -5677,6 +4875,26 @@
               <a:buNone/>
             </a:pPr>
             <a:r>
+              <a:rPr lang="en-US" sz="1150" b="1" dirty="0">
+                <a:solidFill>
+                  <a:srgbClr val="0E2B29"/>
+                </a:solidFill>
+                <a:latin typeface="Arial" pitchFamily="34" charset="0"/>
+                <a:ea typeface="Arial" pitchFamily="34" charset="-122"/>
+                <a:cs typeface="Arial" pitchFamily="34" charset="-120"/>
+              </a:rPr>
+              <a:t>Cohere embed-multilingual-v3 + BM25-lite + RRF (k=60)</a:t>
+            </a:r>
+            <a:pPr algn="l" indent="0" marL="0">
+              <a:lnSpc>
+                <a:spcPts val="1667"/>
+              </a:lnSpc>
+              <a:spcAft>
+                <a:spcPts val="500"/>
+              </a:spcAft>
+              <a:buNone/>
+            </a:pPr>
+            <a:r>
               <a:rPr lang="en-US" sz="1150" dirty="0">
                 <a:solidFill>
                   <a:srgbClr val="0E2B29"/>
@@ -5685,7 +4903,7 @@
                 <a:ea typeface="Arial" pitchFamily="34" charset="-122"/>
                 <a:cs typeface="Arial" pitchFamily="34" charset="-120"/>
               </a:rPr>
-              <a:t> task loop, Human-in-the-loop, RAG hybrid, định tuyến 6 phòng.</a:t>
+              <a:t>.</a:t>
             </a:r>
             <a:endParaRPr lang="en-US" sz="1150" dirty="0"/>
           </a:p>
@@ -5701,15 +4919,15 @@
               <a:buChar char="•"/>
             </a:pPr>
             <a:r>
-              <a:rPr lang="en-US" sz="1150" b="1" dirty="0">
-                <a:solidFill>
-                  <a:srgbClr val="0E2B29"/>
-                </a:solidFill>
-                <a:latin typeface="Arial" pitchFamily="34" charset="0"/>
-                <a:ea typeface="Arial" pitchFamily="34" charset="-122"/>
-                <a:cs typeface="Arial" pitchFamily="34" charset="-120"/>
-              </a:rPr>
-              <a:t>Realtime:</a:t>
+              <a:rPr lang="en-US" sz="1150" dirty="0">
+                <a:solidFill>
+                  <a:srgbClr val="0E2B29"/>
+                </a:solidFill>
+                <a:latin typeface="Arial" pitchFamily="34" charset="0"/>
+                <a:ea typeface="Arial" pitchFamily="34" charset="-122"/>
+                <a:cs typeface="Arial" pitchFamily="34" charset="-120"/>
+              </a:rPr>
+              <a:t>Trả lời có dẫn chứng — trích </a:t>
             </a:r>
             <a:pPr algn="l" indent="0" marL="0">
               <a:lnSpc>
@@ -5721,6 +4939,26 @@
               <a:buNone/>
             </a:pPr>
             <a:r>
+              <a:rPr lang="en-US" sz="1150" b="1" dirty="0">
+                <a:solidFill>
+                  <a:srgbClr val="0E2B29"/>
+                </a:solidFill>
+                <a:latin typeface="Arial" pitchFamily="34" charset="0"/>
+                <a:ea typeface="Arial" pitchFamily="34" charset="-122"/>
+                <a:cs typeface="Arial" pitchFamily="34" charset="-120"/>
+              </a:rPr>
+              <a:t>SOP nội bộ</a:t>
+            </a:r>
+            <a:pPr algn="l" indent="0" marL="0">
+              <a:lnSpc>
+                <a:spcPts val="1667"/>
+              </a:lnSpc>
+              <a:spcAft>
+                <a:spcPts val="500"/>
+              </a:spcAft>
+              <a:buNone/>
+            </a:pPr>
+            <a:r>
               <a:rPr lang="en-US" sz="1150" dirty="0">
                 <a:solidFill>
                   <a:srgbClr val="0E2B29"/>
@@ -5729,7 +4967,7 @@
                 <a:ea typeface="Arial" pitchFamily="34" charset="-122"/>
                 <a:cs typeface="Arial" pitchFamily="34" charset="-120"/>
               </a:rPr>
-              <a:t> streaming ~50 review/giây + scheduler tự sinh alert/ticket.</a:t>
+              <a:t> và bảng dữ liệu thật.</a:t>
             </a:r>
             <a:endParaRPr lang="en-US" sz="1150" dirty="0"/>
           </a:p>
@@ -5745,15 +4983,15 @@
               <a:buChar char="•"/>
             </a:pPr>
             <a:r>
-              <a:rPr lang="en-US" sz="1150" b="1" dirty="0">
-                <a:solidFill>
-                  <a:srgbClr val="0E2B29"/>
-                </a:solidFill>
-                <a:latin typeface="Arial" pitchFamily="34" charset="0"/>
-                <a:ea typeface="Arial" pitchFamily="34" charset="-122"/>
-                <a:cs typeface="Arial" pitchFamily="34" charset="-120"/>
-              </a:rPr>
-              <a:t>Bằng chứng:</a:t>
+              <a:rPr lang="en-US" sz="1150" dirty="0">
+                <a:solidFill>
+                  <a:srgbClr val="0E2B29"/>
+                </a:solidFill>
+                <a:latin typeface="Arial" pitchFamily="34" charset="0"/>
+                <a:ea typeface="Arial" pitchFamily="34" charset="-122"/>
+                <a:cs typeface="Arial" pitchFamily="34" charset="-120"/>
+              </a:rPr>
+              <a:t>Phân quyền tự động: </a:t>
             </a:r>
             <a:pPr algn="l" indent="0" marL="0">
               <a:lnSpc>
@@ -5765,6 +5003,26 @@
               <a:buNone/>
             </a:pPr>
             <a:r>
+              <a:rPr lang="en-US" sz="1150" b="1" dirty="0">
+                <a:solidFill>
+                  <a:srgbClr val="0E2B29"/>
+                </a:solidFill>
+                <a:latin typeface="Arial" pitchFamily="34" charset="0"/>
+                <a:ea typeface="Arial" pitchFamily="34" charset="-122"/>
+                <a:cs typeface="Arial" pitchFamily="34" charset="-120"/>
+              </a:rPr>
+              <a:t>Guest</a:t>
+            </a:r>
+            <a:pPr algn="l" indent="0" marL="0">
+              <a:lnSpc>
+                <a:spcPts val="1667"/>
+              </a:lnSpc>
+              <a:spcAft>
+                <a:spcPts val="500"/>
+              </a:spcAft>
+              <a:buNone/>
+            </a:pPr>
+            <a:r>
               <a:rPr lang="en-US" sz="1150" dirty="0">
                 <a:solidFill>
                   <a:srgbClr val="0E2B29"/>
@@ -5773,7 +5031,47 @@
                 <a:ea typeface="Arial" pitchFamily="34" charset="-122"/>
                 <a:cs typeface="Arial" pitchFamily="34" charset="-120"/>
               </a:rPr>
-              <a:t> chạy trên dữ liệu review tiếng Việt thật từ App Store/Google Play.</a:t>
+              <a:t> chỉ FAQ công khai, </a:t>
+            </a:r>
+            <a:pPr algn="l" indent="0" marL="0">
+              <a:lnSpc>
+                <a:spcPts val="1667"/>
+              </a:lnSpc>
+              <a:spcAft>
+                <a:spcPts val="500"/>
+              </a:spcAft>
+              <a:buNone/>
+            </a:pPr>
+            <a:r>
+              <a:rPr lang="en-US" sz="1150" b="1" dirty="0">
+                <a:solidFill>
+                  <a:srgbClr val="0E2B29"/>
+                </a:solidFill>
+                <a:latin typeface="Arial" pitchFamily="34" charset="0"/>
+                <a:ea typeface="Arial" pitchFamily="34" charset="-122"/>
+                <a:cs typeface="Arial" pitchFamily="34" charset="-120"/>
+              </a:rPr>
+              <a:t>Staff</a:t>
+            </a:r>
+            <a:pPr algn="l" indent="0" marL="0">
+              <a:lnSpc>
+                <a:spcPts val="1667"/>
+              </a:lnSpc>
+              <a:spcAft>
+                <a:spcPts val="500"/>
+              </a:spcAft>
+              <a:buNone/>
+            </a:pPr>
+            <a:r>
+              <a:rPr lang="en-US" sz="1150" dirty="0">
+                <a:solidFill>
+                  <a:srgbClr val="0E2B29"/>
+                </a:solidFill>
+                <a:latin typeface="Arial" pitchFamily="34" charset="0"/>
+                <a:ea typeface="Arial" pitchFamily="34" charset="-122"/>
+                <a:cs typeface="Arial" pitchFamily="34" charset="-120"/>
+              </a:rPr>
+              <a:t> thấy nội bộ.</a:t>
             </a:r>
             <a:endParaRPr lang="en-US" sz="1150" dirty="0"/>
           </a:p>
@@ -5789,26 +5087,6 @@
               <a:buChar char="•"/>
             </a:pPr>
             <a:r>
-              <a:rPr lang="en-US" sz="1150" b="1" dirty="0">
-                <a:solidFill>
-                  <a:srgbClr val="0E2B29"/>
-                </a:solidFill>
-                <a:latin typeface="Arial" pitchFamily="34" charset="0"/>
-                <a:ea typeface="Arial" pitchFamily="34" charset="-122"/>
-                <a:cs typeface="Arial" pitchFamily="34" charset="-120"/>
-              </a:rPr>
-              <a:t>Tiếp theo:</a:t>
-            </a:r>
-            <a:pPr algn="l" indent="0" marL="0">
-              <a:lnSpc>
-                <a:spcPts val="1667"/>
-              </a:lnSpc>
-              <a:spcAft>
-                <a:spcPts val="500"/>
-              </a:spcAft>
-              <a:buNone/>
-            </a:pPr>
-            <a:r>
               <a:rPr lang="en-US" sz="1150" dirty="0">
                 <a:solidFill>
                   <a:srgbClr val="0E2B29"/>
@@ -5817,7 +5095,7 @@
                 <a:ea typeface="Arial" pitchFamily="34" charset="-122"/>
                 <a:cs typeface="Arial" pitchFamily="34" charset="-120"/>
               </a:rPr>
-              <a:t> mở rộng KB nội bộ cho 6 phòng, tinh chỉnh ML &amp; đánh giá agent.</a:t>
+              <a:t>Cùng một giao diện chat — quyền truy cập đổi theo role.</a:t>
             </a:r>
             <a:endParaRPr lang="en-US" sz="1150" dirty="0"/>
           </a:p>
@@ -5831,7 +5109,7 @@
         </p:nvSpPr>
         <p:spPr>
           <a:xfrm>
-            <a:off x="3632299" y="1018877"/>
+            <a:off x="3632299" y="1076027"/>
             <a:ext cx="5130701" cy="3262759"/>
           </a:xfrm>
           <a:prstGeom prst="roundRect">
@@ -5868,7 +5146,7 @@
       </p:sp>
       <p:pic>
         <p:nvPicPr>
-          <p:cNvPr id="6" name="Image 0" descr="/private/tmp/claude-501/-Users-kenz-de-projects-C2-App-116/3d8df5ac-6b2b-4cce-a997-fe0b4573b465/scratchpad/build/assets/dashboard.png">    </p:cNvPr>
+          <p:cNvPr id="6" name="Image 0" descr="/private/tmp/claude-501/-Users-kenz-de-projects-C2-App-116/3d8df5ac-6b2b-4cce-a997-fe0b4573b465/scratchpad/build/assets/chat.png">    </p:cNvPr>
           <p:cNvPicPr>
             <a:picLocks noChangeAspect="1"/>
           </p:cNvPicPr>
@@ -5882,7 +5160,7 @@
         </p:blipFill>
         <p:spPr>
           <a:xfrm>
-            <a:off x="3705225" y="1091803"/>
+            <a:off x="3705225" y="1148953"/>
             <a:ext cx="4984849" cy="3116907"/>
           </a:xfrm>
           <a:prstGeom prst="rect">
@@ -5943,6 +5221,2052 @@
 <file path=ppt/slides/slide15.xml><?xml version="1.0" encoding="utf-8"?>
 <p:sld xmlns:a="http://schemas.openxmlformats.org/drawingml/2006/main" xmlns:r="http://schemas.openxmlformats.org/officeDocument/2006/relationships" xmlns:p="http://schemas.openxmlformats.org/presentationml/2006/main">
   <p:cSld name="Slide 15">
+    <p:bg>
+      <p:bgPr>
+        <a:solidFill>
+          <a:srgbClr val="FFFFFF"/>
+        </a:solidFill>
+      </p:bgPr>
+    </p:bg>
+    <p:spTree>
+      <p:nvGrpSpPr>
+        <p:cNvPr id="1" name=""/>
+        <p:cNvGrpSpPr/>
+        <p:nvPr/>
+      </p:nvGrpSpPr>
+      <p:grpSpPr>
+        <a:xfrm>
+          <a:off x="0" y="0"/>
+          <a:ext cx="0" cy="0"/>
+          <a:chOff x="0" y="0"/>
+          <a:chExt cx="0" cy="0"/>
+        </a:xfrm>
+      </p:grpSpPr>
+      <p:sp>
+        <p:nvSpPr>
+          <p:cNvPr id="2" name="Text 0"/>
+          <p:cNvSpPr/>
+          <p:nvPr/>
+        </p:nvSpPr>
+        <p:spPr>
+          <a:xfrm>
+            <a:off x="381000" y="330101"/>
+            <a:ext cx="8549640" cy="142875"/>
+          </a:xfrm>
+          <a:prstGeom prst="rect">
+            <a:avLst/>
+          </a:prstGeom>
+          <a:noFill/>
+          <a:ln/>
+        </p:spPr>
+        <p:txBody>
+          <a:bodyPr wrap="square" lIns="0" tIns="0" rIns="0" bIns="0" rtlCol="0" anchor="t"/>
+          <a:lstStyle/>
+          <a:p>
+            <a:pPr algn="l" indent="0" marL="0">
+              <a:spcAft>
+                <a:spcPts val="400"/>
+              </a:spcAft>
+              <a:buNone/>
+            </a:pPr>
+            <a:r>
+              <a:rPr lang="en-US" sz="1000" b="1" dirty="0">
+                <a:solidFill>
+                  <a:srgbClr val="0E8C84"/>
+                </a:solidFill>
+                <a:latin typeface="Arial" pitchFamily="34" charset="0"/>
+                <a:ea typeface="Arial" pitchFamily="34" charset="-122"/>
+                <a:cs typeface="Arial" pitchFamily="34" charset="-120"/>
+              </a:rPr>
+              <a:t>TƯ DUY SẢN PHẨM</a:t>
+            </a:r>
+            <a:endParaRPr lang="en-US" sz="1000" dirty="0"/>
+          </a:p>
+        </p:txBody>
+      </p:sp>
+      <p:sp>
+        <p:nvSpPr>
+          <p:cNvPr id="3" name="Text 1"/>
+          <p:cNvSpPr/>
+          <p:nvPr/>
+        </p:nvSpPr>
+        <p:spPr>
+          <a:xfrm>
+            <a:off x="381000" y="523726"/>
+            <a:ext cx="8549640" cy="342751"/>
+          </a:xfrm>
+          <a:prstGeom prst="rect">
+            <a:avLst/>
+          </a:prstGeom>
+          <a:noFill/>
+          <a:ln/>
+        </p:spPr>
+        <p:txBody>
+          <a:bodyPr wrap="square" lIns="0" tIns="0" rIns="0" bIns="0" rtlCol="0" anchor="t"/>
+          <a:lstStyle/>
+          <a:p>
+            <a:pPr algn="l" indent="0" marL="0">
+              <a:lnSpc>
+                <a:spcPts val="2700"/>
+              </a:lnSpc>
+              <a:buNone/>
+            </a:pPr>
+            <a:r>
+              <a:rPr lang="en-US" sz="2500" b="1" dirty="0">
+                <a:solidFill>
+                  <a:srgbClr val="0B5E5C"/>
+                </a:solidFill>
+                <a:latin typeface="Arial" pitchFamily="34" charset="0"/>
+                <a:ea typeface="Arial" pitchFamily="34" charset="-122"/>
+                <a:cs typeface="Arial" pitchFamily="34" charset="-120"/>
+              </a:rPr>
+              <a:t>Năm nguyên tắc định hình mọi quyết định</a:t>
+            </a:r>
+            <a:endParaRPr lang="en-US" sz="2500" dirty="0"/>
+          </a:p>
+        </p:txBody>
+      </p:sp>
+      <p:sp>
+        <p:nvSpPr>
+          <p:cNvPr id="4" name="Text 2"/>
+          <p:cNvSpPr/>
+          <p:nvPr/>
+        </p:nvSpPr>
+        <p:spPr>
+          <a:xfrm>
+            <a:off x="381000" y="1069628"/>
+            <a:ext cx="1554361" cy="2686050"/>
+          </a:xfrm>
+          <a:prstGeom prst="roundRect">
+            <a:avLst>
+              <a:gd name="adj" fmla="val 8171"/>
+            </a:avLst>
+          </a:prstGeom>
+          <a:solidFill>
+            <a:srgbClr val="FFFFFF"/>
+          </a:solidFill>
+          <a:ln/>
+        </p:spPr>
+        <p:txBody>
+          <a:bodyPr wrap="square" rtlCol="0" anchor="ctr"/>
+          <a:lstStyle/>
+          <a:p>
+            <a:pPr indent="0" marL="0">
+              <a:buNone/>
+            </a:pPr>
+            <a:endParaRPr lang="en-US" dirty="0"/>
+          </a:p>
+        </p:txBody>
+      </p:sp>
+      <p:sp>
+        <p:nvSpPr>
+          <p:cNvPr id="5" name="Shape 3"/>
+          <p:cNvSpPr/>
+          <p:nvPr/>
+        </p:nvSpPr>
+        <p:spPr>
+          <a:xfrm>
+            <a:off x="381000" y="1093440"/>
+            <a:ext cx="1554361" cy="0"/>
+          </a:xfrm>
+          <a:prstGeom prst="line">
+            <a:avLst/>
+          </a:prstGeom>
+          <a:noFill/>
+          <a:ln w="47625">
+            <a:solidFill>
+              <a:srgbClr val="0E8C84"/>
+            </a:solidFill>
+            <a:prstDash val="solid"/>
+          </a:ln>
+        </p:spPr>
+      </p:sp>
+      <p:sp>
+        <p:nvSpPr>
+          <p:cNvPr id="6" name="Shape 4"/>
+          <p:cNvSpPr/>
+          <p:nvPr/>
+        </p:nvSpPr>
+        <p:spPr>
+          <a:xfrm>
+            <a:off x="1930598" y="1069628"/>
+            <a:ext cx="0" cy="2686050"/>
+          </a:xfrm>
+          <a:prstGeom prst="line">
+            <a:avLst/>
+          </a:prstGeom>
+          <a:noFill/>
+          <a:ln w="9525">
+            <a:solidFill>
+              <a:srgbClr val="D9E8E4"/>
+            </a:solidFill>
+            <a:prstDash val="solid"/>
+          </a:ln>
+        </p:spPr>
+      </p:sp>
+      <p:sp>
+        <p:nvSpPr>
+          <p:cNvPr id="7" name="Shape 5"/>
+          <p:cNvSpPr/>
+          <p:nvPr/>
+        </p:nvSpPr>
+        <p:spPr>
+          <a:xfrm>
+            <a:off x="381000" y="3750915"/>
+            <a:ext cx="1554361" cy="0"/>
+          </a:xfrm>
+          <a:prstGeom prst="line">
+            <a:avLst/>
+          </a:prstGeom>
+          <a:noFill/>
+          <a:ln w="9525">
+            <a:solidFill>
+              <a:srgbClr val="D9E8E4"/>
+            </a:solidFill>
+            <a:prstDash val="solid"/>
+          </a:ln>
+        </p:spPr>
+      </p:sp>
+      <p:sp>
+        <p:nvSpPr>
+          <p:cNvPr id="8" name="Shape 6"/>
+          <p:cNvSpPr/>
+          <p:nvPr/>
+        </p:nvSpPr>
+        <p:spPr>
+          <a:xfrm>
+            <a:off x="385763" y="1069628"/>
+            <a:ext cx="0" cy="2686050"/>
+          </a:xfrm>
+          <a:prstGeom prst="line">
+            <a:avLst/>
+          </a:prstGeom>
+          <a:noFill/>
+          <a:ln w="9525">
+            <a:solidFill>
+              <a:srgbClr val="D9E8E4"/>
+            </a:solidFill>
+            <a:prstDash val="solid"/>
+          </a:ln>
+        </p:spPr>
+      </p:sp>
+      <p:sp>
+        <p:nvSpPr>
+          <p:cNvPr id="9" name="Text 7"/>
+          <p:cNvSpPr/>
+          <p:nvPr/>
+        </p:nvSpPr>
+        <p:spPr>
+          <a:xfrm>
+            <a:off x="542925" y="1269653"/>
+            <a:ext cx="1255121" cy="238125"/>
+          </a:xfrm>
+          <a:prstGeom prst="rect">
+            <a:avLst/>
+          </a:prstGeom>
+          <a:noFill/>
+          <a:ln/>
+        </p:spPr>
+        <p:txBody>
+          <a:bodyPr wrap="square" lIns="0" tIns="0" rIns="0" bIns="0" rtlCol="0" anchor="t"/>
+          <a:lstStyle/>
+          <a:p>
+            <a:pPr algn="l" indent="0" marL="0">
+              <a:buNone/>
+            </a:pPr>
+            <a:r>
+              <a:rPr lang="en-US" sz="1600" b="1" dirty="0">
+                <a:solidFill>
+                  <a:srgbClr val="34D399"/>
+                </a:solidFill>
+                <a:latin typeface="Arial" pitchFamily="34" charset="0"/>
+                <a:ea typeface="Arial" pitchFamily="34" charset="-122"/>
+                <a:cs typeface="Arial" pitchFamily="34" charset="-120"/>
+              </a:rPr>
+              <a:t>01</a:t>
+            </a:r>
+            <a:endParaRPr lang="en-US" sz="1600" dirty="0"/>
+          </a:p>
+        </p:txBody>
+      </p:sp>
+      <p:sp>
+        <p:nvSpPr>
+          <p:cNvPr id="10" name="Text 8"/>
+          <p:cNvSpPr/>
+          <p:nvPr/>
+        </p:nvSpPr>
+        <p:spPr>
+          <a:xfrm>
+            <a:off x="542925" y="1571179"/>
+            <a:ext cx="1255121" cy="349151"/>
+          </a:xfrm>
+          <a:prstGeom prst="rect">
+            <a:avLst/>
+          </a:prstGeom>
+          <a:noFill/>
+          <a:ln/>
+        </p:spPr>
+        <p:txBody>
+          <a:bodyPr wrap="square" lIns="0" tIns="0" rIns="0" bIns="0" rtlCol="0" anchor="t"/>
+          <a:lstStyle/>
+          <a:p>
+            <a:pPr algn="l" indent="0" marL="0">
+              <a:lnSpc>
+                <a:spcPts val="1375"/>
+              </a:lnSpc>
+              <a:spcBef>
+                <a:spcPts val="500"/>
+              </a:spcBef>
+              <a:buNone/>
+            </a:pPr>
+            <a:r>
+              <a:rPr lang="en-US" sz="1100" b="1" dirty="0">
+                <a:solidFill>
+                  <a:srgbClr val="0B5E5C"/>
+                </a:solidFill>
+                <a:latin typeface="Arial" pitchFamily="34" charset="0"/>
+                <a:ea typeface="Arial" pitchFamily="34" charset="-122"/>
+                <a:cs typeface="Arial" pitchFamily="34" charset="-120"/>
+              </a:rPr>
+              <a:t>An toàn không nhường xác suất</a:t>
+            </a:r>
+            <a:endParaRPr lang="en-US" sz="1100" dirty="0"/>
+          </a:p>
+        </p:txBody>
+      </p:sp>
+      <p:sp>
+        <p:nvSpPr>
+          <p:cNvPr id="11" name="Text 9"/>
+          <p:cNvSpPr/>
+          <p:nvPr/>
+        </p:nvSpPr>
+        <p:spPr>
+          <a:xfrm>
+            <a:off x="542925" y="1983730"/>
+            <a:ext cx="1255121" cy="297061"/>
+          </a:xfrm>
+          <a:prstGeom prst="rect">
+            <a:avLst/>
+          </a:prstGeom>
+          <a:noFill/>
+          <a:ln/>
+        </p:spPr>
+        <p:txBody>
+          <a:bodyPr wrap="square" lIns="0" tIns="0" rIns="0" bIns="0" rtlCol="0" anchor="t"/>
+          <a:lstStyle/>
+          <a:p>
+            <a:pPr algn="l" indent="0" marL="0">
+              <a:lnSpc>
+                <a:spcPts val="1170"/>
+              </a:lnSpc>
+              <a:spcBef>
+                <a:spcPts val="500"/>
+              </a:spcBef>
+              <a:buNone/>
+            </a:pPr>
+            <a:r>
+              <a:rPr lang="en-US" sz="900" dirty="0">
+                <a:solidFill>
+                  <a:srgbClr val="5C7470"/>
+                </a:solidFill>
+                <a:latin typeface="Arial" pitchFamily="34" charset="0"/>
+                <a:ea typeface="Arial" pitchFamily="34" charset="-122"/>
+                <a:cs typeface="Arial" pitchFamily="34" charset="-120"/>
+              </a:rPr>
+              <a:t>Rule safety ép P5 dù model nghĩ khác.</a:t>
+            </a:r>
+            <a:endParaRPr lang="en-US" sz="900" dirty="0"/>
+          </a:p>
+        </p:txBody>
+      </p:sp>
+      <p:sp>
+        <p:nvSpPr>
+          <p:cNvPr id="12" name="Text 10"/>
+          <p:cNvSpPr/>
+          <p:nvPr/>
+        </p:nvSpPr>
+        <p:spPr>
+          <a:xfrm>
+            <a:off x="2087761" y="1069628"/>
+            <a:ext cx="1554510" cy="2686050"/>
+          </a:xfrm>
+          <a:prstGeom prst="roundRect">
+            <a:avLst>
+              <a:gd name="adj" fmla="val 8170"/>
+            </a:avLst>
+          </a:prstGeom>
+          <a:solidFill>
+            <a:srgbClr val="FFFFFF"/>
+          </a:solidFill>
+          <a:ln/>
+        </p:spPr>
+        <p:txBody>
+          <a:bodyPr wrap="square" rtlCol="0" anchor="ctr"/>
+          <a:lstStyle/>
+          <a:p>
+            <a:pPr indent="0" marL="0">
+              <a:buNone/>
+            </a:pPr>
+            <a:endParaRPr lang="en-US" dirty="0"/>
+          </a:p>
+        </p:txBody>
+      </p:sp>
+      <p:sp>
+        <p:nvSpPr>
+          <p:cNvPr id="13" name="Shape 11"/>
+          <p:cNvSpPr/>
+          <p:nvPr/>
+        </p:nvSpPr>
+        <p:spPr>
+          <a:xfrm>
+            <a:off x="2087761" y="1093440"/>
+            <a:ext cx="1554510" cy="0"/>
+          </a:xfrm>
+          <a:prstGeom prst="line">
+            <a:avLst/>
+          </a:prstGeom>
+          <a:noFill/>
+          <a:ln w="47625">
+            <a:solidFill>
+              <a:srgbClr val="0E8C84"/>
+            </a:solidFill>
+            <a:prstDash val="solid"/>
+          </a:ln>
+        </p:spPr>
+      </p:sp>
+      <p:sp>
+        <p:nvSpPr>
+          <p:cNvPr id="14" name="Shape 12"/>
+          <p:cNvSpPr/>
+          <p:nvPr/>
+        </p:nvSpPr>
+        <p:spPr>
+          <a:xfrm>
+            <a:off x="3637508" y="1069628"/>
+            <a:ext cx="0" cy="2686050"/>
+          </a:xfrm>
+          <a:prstGeom prst="line">
+            <a:avLst/>
+          </a:prstGeom>
+          <a:noFill/>
+          <a:ln w="9525">
+            <a:solidFill>
+              <a:srgbClr val="D9E8E4"/>
+            </a:solidFill>
+            <a:prstDash val="solid"/>
+          </a:ln>
+        </p:spPr>
+      </p:sp>
+      <p:sp>
+        <p:nvSpPr>
+          <p:cNvPr id="15" name="Shape 13"/>
+          <p:cNvSpPr/>
+          <p:nvPr/>
+        </p:nvSpPr>
+        <p:spPr>
+          <a:xfrm>
+            <a:off x="2087761" y="3750915"/>
+            <a:ext cx="1554510" cy="0"/>
+          </a:xfrm>
+          <a:prstGeom prst="line">
+            <a:avLst/>
+          </a:prstGeom>
+          <a:noFill/>
+          <a:ln w="9525">
+            <a:solidFill>
+              <a:srgbClr val="D9E8E4"/>
+            </a:solidFill>
+            <a:prstDash val="solid"/>
+          </a:ln>
+        </p:spPr>
+      </p:sp>
+      <p:sp>
+        <p:nvSpPr>
+          <p:cNvPr id="16" name="Shape 14"/>
+          <p:cNvSpPr/>
+          <p:nvPr/>
+        </p:nvSpPr>
+        <p:spPr>
+          <a:xfrm>
+            <a:off x="2092523" y="1069628"/>
+            <a:ext cx="0" cy="2686050"/>
+          </a:xfrm>
+          <a:prstGeom prst="line">
+            <a:avLst/>
+          </a:prstGeom>
+          <a:noFill/>
+          <a:ln w="9525">
+            <a:solidFill>
+              <a:srgbClr val="D9E8E4"/>
+            </a:solidFill>
+            <a:prstDash val="solid"/>
+          </a:ln>
+        </p:spPr>
+      </p:sp>
+      <p:sp>
+        <p:nvSpPr>
+          <p:cNvPr id="17" name="Text 15"/>
+          <p:cNvSpPr/>
+          <p:nvPr/>
+        </p:nvSpPr>
+        <p:spPr>
+          <a:xfrm>
+            <a:off x="2249686" y="1269653"/>
+            <a:ext cx="1255273" cy="238125"/>
+          </a:xfrm>
+          <a:prstGeom prst="rect">
+            <a:avLst/>
+          </a:prstGeom>
+          <a:noFill/>
+          <a:ln/>
+        </p:spPr>
+        <p:txBody>
+          <a:bodyPr wrap="square" lIns="0" tIns="0" rIns="0" bIns="0" rtlCol="0" anchor="t"/>
+          <a:lstStyle/>
+          <a:p>
+            <a:pPr algn="l" indent="0" marL="0">
+              <a:buNone/>
+            </a:pPr>
+            <a:r>
+              <a:rPr lang="en-US" sz="1600" b="1" dirty="0">
+                <a:solidFill>
+                  <a:srgbClr val="34D399"/>
+                </a:solidFill>
+                <a:latin typeface="Arial" pitchFamily="34" charset="0"/>
+                <a:ea typeface="Arial" pitchFamily="34" charset="-122"/>
+                <a:cs typeface="Arial" pitchFamily="34" charset="-120"/>
+              </a:rPr>
+              <a:t>02</a:t>
+            </a:r>
+            <a:endParaRPr lang="en-US" sz="1600" dirty="0"/>
+          </a:p>
+        </p:txBody>
+      </p:sp>
+      <p:sp>
+        <p:nvSpPr>
+          <p:cNvPr id="18" name="Text 16"/>
+          <p:cNvSpPr/>
+          <p:nvPr/>
+        </p:nvSpPr>
+        <p:spPr>
+          <a:xfrm>
+            <a:off x="2249686" y="1571179"/>
+            <a:ext cx="1255273" cy="349151"/>
+          </a:xfrm>
+          <a:prstGeom prst="rect">
+            <a:avLst/>
+          </a:prstGeom>
+          <a:noFill/>
+          <a:ln/>
+        </p:spPr>
+        <p:txBody>
+          <a:bodyPr wrap="square" lIns="0" tIns="0" rIns="0" bIns="0" rtlCol="0" anchor="t"/>
+          <a:lstStyle/>
+          <a:p>
+            <a:pPr algn="l" indent="0" marL="0">
+              <a:lnSpc>
+                <a:spcPts val="1375"/>
+              </a:lnSpc>
+              <a:spcBef>
+                <a:spcPts val="500"/>
+              </a:spcBef>
+              <a:buNone/>
+            </a:pPr>
+            <a:r>
+              <a:rPr lang="en-US" sz="1100" b="1" dirty="0">
+                <a:solidFill>
+                  <a:srgbClr val="0B5E5C"/>
+                </a:solidFill>
+                <a:latin typeface="Arial" pitchFamily="34" charset="0"/>
+                <a:ea typeface="Arial" pitchFamily="34" charset="-122"/>
+                <a:cs typeface="Arial" pitchFamily="34" charset="-120"/>
+              </a:rPr>
+              <a:t>Human-in-the-loop</a:t>
+            </a:r>
+            <a:endParaRPr lang="en-US" sz="1100" dirty="0"/>
+          </a:p>
+        </p:txBody>
+      </p:sp>
+      <p:sp>
+        <p:nvSpPr>
+          <p:cNvPr id="19" name="Text 17"/>
+          <p:cNvSpPr/>
+          <p:nvPr/>
+        </p:nvSpPr>
+        <p:spPr>
+          <a:xfrm>
+            <a:off x="2249686" y="1983730"/>
+            <a:ext cx="1255273" cy="445591"/>
+          </a:xfrm>
+          <a:prstGeom prst="rect">
+            <a:avLst/>
+          </a:prstGeom>
+          <a:noFill/>
+          <a:ln/>
+        </p:spPr>
+        <p:txBody>
+          <a:bodyPr wrap="square" lIns="0" tIns="0" rIns="0" bIns="0" rtlCol="0" anchor="t"/>
+          <a:lstStyle/>
+          <a:p>
+            <a:pPr algn="l" indent="0" marL="0">
+              <a:lnSpc>
+                <a:spcPts val="1170"/>
+              </a:lnSpc>
+              <a:spcBef>
+                <a:spcPts val="500"/>
+              </a:spcBef>
+              <a:buNone/>
+            </a:pPr>
+            <a:r>
+              <a:rPr lang="en-US" sz="900" dirty="0">
+                <a:solidFill>
+                  <a:srgbClr val="5C7470"/>
+                </a:solidFill>
+                <a:latin typeface="Arial" pitchFamily="34" charset="0"/>
+                <a:ea typeface="Arial" pitchFamily="34" charset="-122"/>
+                <a:cs typeface="Arial" pitchFamily="34" charset="-120"/>
+              </a:rPr>
+              <a:t>Máy đề xuất, con người quyết &amp; chịu trách nhiệm.</a:t>
+            </a:r>
+            <a:endParaRPr lang="en-US" sz="900" dirty="0"/>
+          </a:p>
+        </p:txBody>
+      </p:sp>
+      <p:sp>
+        <p:nvSpPr>
+          <p:cNvPr id="20" name="Text 18"/>
+          <p:cNvSpPr/>
+          <p:nvPr/>
+        </p:nvSpPr>
+        <p:spPr>
+          <a:xfrm>
+            <a:off x="3794671" y="1069628"/>
+            <a:ext cx="1554510" cy="2686050"/>
+          </a:xfrm>
+          <a:prstGeom prst="roundRect">
+            <a:avLst>
+              <a:gd name="adj" fmla="val 8170"/>
+            </a:avLst>
+          </a:prstGeom>
+          <a:solidFill>
+            <a:srgbClr val="FFFFFF"/>
+          </a:solidFill>
+          <a:ln/>
+        </p:spPr>
+        <p:txBody>
+          <a:bodyPr wrap="square" rtlCol="0" anchor="ctr"/>
+          <a:lstStyle/>
+          <a:p>
+            <a:pPr indent="0" marL="0">
+              <a:buNone/>
+            </a:pPr>
+            <a:endParaRPr lang="en-US" dirty="0"/>
+          </a:p>
+        </p:txBody>
+      </p:sp>
+      <p:sp>
+        <p:nvSpPr>
+          <p:cNvPr id="21" name="Shape 19"/>
+          <p:cNvSpPr/>
+          <p:nvPr/>
+        </p:nvSpPr>
+        <p:spPr>
+          <a:xfrm>
+            <a:off x="3794671" y="1093440"/>
+            <a:ext cx="1554510" cy="0"/>
+          </a:xfrm>
+          <a:prstGeom prst="line">
+            <a:avLst/>
+          </a:prstGeom>
+          <a:noFill/>
+          <a:ln w="47625">
+            <a:solidFill>
+              <a:srgbClr val="0E8C84"/>
+            </a:solidFill>
+            <a:prstDash val="solid"/>
+          </a:ln>
+        </p:spPr>
+      </p:sp>
+      <p:sp>
+        <p:nvSpPr>
+          <p:cNvPr id="22" name="Shape 20"/>
+          <p:cNvSpPr/>
+          <p:nvPr/>
+        </p:nvSpPr>
+        <p:spPr>
+          <a:xfrm>
+            <a:off x="5344418" y="1069628"/>
+            <a:ext cx="0" cy="2686050"/>
+          </a:xfrm>
+          <a:prstGeom prst="line">
+            <a:avLst/>
+          </a:prstGeom>
+          <a:noFill/>
+          <a:ln w="9525">
+            <a:solidFill>
+              <a:srgbClr val="D9E8E4"/>
+            </a:solidFill>
+            <a:prstDash val="solid"/>
+          </a:ln>
+        </p:spPr>
+      </p:sp>
+      <p:sp>
+        <p:nvSpPr>
+          <p:cNvPr id="23" name="Shape 21"/>
+          <p:cNvSpPr/>
+          <p:nvPr/>
+        </p:nvSpPr>
+        <p:spPr>
+          <a:xfrm>
+            <a:off x="3794671" y="3750915"/>
+            <a:ext cx="1554510" cy="0"/>
+          </a:xfrm>
+          <a:prstGeom prst="line">
+            <a:avLst/>
+          </a:prstGeom>
+          <a:noFill/>
+          <a:ln w="9525">
+            <a:solidFill>
+              <a:srgbClr val="D9E8E4"/>
+            </a:solidFill>
+            <a:prstDash val="solid"/>
+          </a:ln>
+        </p:spPr>
+      </p:sp>
+      <p:sp>
+        <p:nvSpPr>
+          <p:cNvPr id="24" name="Shape 22"/>
+          <p:cNvSpPr/>
+          <p:nvPr/>
+        </p:nvSpPr>
+        <p:spPr>
+          <a:xfrm>
+            <a:off x="3799433" y="1069628"/>
+            <a:ext cx="0" cy="2686050"/>
+          </a:xfrm>
+          <a:prstGeom prst="line">
+            <a:avLst/>
+          </a:prstGeom>
+          <a:noFill/>
+          <a:ln w="9525">
+            <a:solidFill>
+              <a:srgbClr val="D9E8E4"/>
+            </a:solidFill>
+            <a:prstDash val="solid"/>
+          </a:ln>
+        </p:spPr>
+      </p:sp>
+      <p:sp>
+        <p:nvSpPr>
+          <p:cNvPr id="25" name="Text 23"/>
+          <p:cNvSpPr/>
+          <p:nvPr/>
+        </p:nvSpPr>
+        <p:spPr>
+          <a:xfrm>
+            <a:off x="3956596" y="1269653"/>
+            <a:ext cx="1255273" cy="238125"/>
+          </a:xfrm>
+          <a:prstGeom prst="rect">
+            <a:avLst/>
+          </a:prstGeom>
+          <a:noFill/>
+          <a:ln/>
+        </p:spPr>
+        <p:txBody>
+          <a:bodyPr wrap="square" lIns="0" tIns="0" rIns="0" bIns="0" rtlCol="0" anchor="t"/>
+          <a:lstStyle/>
+          <a:p>
+            <a:pPr algn="l" indent="0" marL="0">
+              <a:buNone/>
+            </a:pPr>
+            <a:r>
+              <a:rPr lang="en-US" sz="1600" b="1" dirty="0">
+                <a:solidFill>
+                  <a:srgbClr val="34D399"/>
+                </a:solidFill>
+                <a:latin typeface="Arial" pitchFamily="34" charset="0"/>
+                <a:ea typeface="Arial" pitchFamily="34" charset="-122"/>
+                <a:cs typeface="Arial" pitchFamily="34" charset="-120"/>
+              </a:rPr>
+              <a:t>03</a:t>
+            </a:r>
+            <a:endParaRPr lang="en-US" sz="1600" dirty="0"/>
+          </a:p>
+        </p:txBody>
+      </p:sp>
+      <p:sp>
+        <p:nvSpPr>
+          <p:cNvPr id="26" name="Text 24"/>
+          <p:cNvSpPr/>
+          <p:nvPr/>
+        </p:nvSpPr>
+        <p:spPr>
+          <a:xfrm>
+            <a:off x="3956596" y="1571179"/>
+            <a:ext cx="1255273" cy="349151"/>
+          </a:xfrm>
+          <a:prstGeom prst="rect">
+            <a:avLst/>
+          </a:prstGeom>
+          <a:noFill/>
+          <a:ln/>
+        </p:spPr>
+        <p:txBody>
+          <a:bodyPr wrap="square" lIns="0" tIns="0" rIns="0" bIns="0" rtlCol="0" anchor="t"/>
+          <a:lstStyle/>
+          <a:p>
+            <a:pPr algn="l" indent="0" marL="0">
+              <a:lnSpc>
+                <a:spcPts val="1375"/>
+              </a:lnSpc>
+              <a:spcBef>
+                <a:spcPts val="500"/>
+              </a:spcBef>
+              <a:buNone/>
+            </a:pPr>
+            <a:r>
+              <a:rPr lang="en-US" sz="1100" b="1" dirty="0">
+                <a:solidFill>
+                  <a:srgbClr val="0B5E5C"/>
+                </a:solidFill>
+                <a:latin typeface="Arial" pitchFamily="34" charset="0"/>
+                <a:ea typeface="Arial" pitchFamily="34" charset="-122"/>
+                <a:cs typeface="Arial" pitchFamily="34" charset="-120"/>
+              </a:rPr>
+              <a:t>Phân quyền tự động</a:t>
+            </a:r>
+            <a:endParaRPr lang="en-US" sz="1100" dirty="0"/>
+          </a:p>
+        </p:txBody>
+      </p:sp>
+      <p:sp>
+        <p:nvSpPr>
+          <p:cNvPr id="27" name="Text 25"/>
+          <p:cNvSpPr/>
+          <p:nvPr/>
+        </p:nvSpPr>
+        <p:spPr>
+          <a:xfrm>
+            <a:off x="3956596" y="1983730"/>
+            <a:ext cx="1255273" cy="297061"/>
+          </a:xfrm>
+          <a:prstGeom prst="rect">
+            <a:avLst/>
+          </a:prstGeom>
+          <a:noFill/>
+          <a:ln/>
+        </p:spPr>
+        <p:txBody>
+          <a:bodyPr wrap="square" lIns="0" tIns="0" rIns="0" bIns="0" rtlCol="0" anchor="t"/>
+          <a:lstStyle/>
+          <a:p>
+            <a:pPr algn="l" indent="0" marL="0">
+              <a:lnSpc>
+                <a:spcPts val="1170"/>
+              </a:lnSpc>
+              <a:spcBef>
+                <a:spcPts val="500"/>
+              </a:spcBef>
+              <a:buNone/>
+            </a:pPr>
+            <a:r>
+              <a:rPr lang="en-US" sz="900" dirty="0">
+                <a:solidFill>
+                  <a:srgbClr val="5C7470"/>
+                </a:solidFill>
+                <a:latin typeface="Arial" pitchFamily="34" charset="0"/>
+                <a:ea typeface="Arial" pitchFamily="34" charset="-122"/>
+                <a:cs typeface="Arial" pitchFamily="34" charset="-120"/>
+              </a:rPr>
+              <a:t>RBAC 4 vai trò, dữ liệu lọc theo role qua RLS.</a:t>
+            </a:r>
+            <a:endParaRPr lang="en-US" sz="900" dirty="0"/>
+          </a:p>
+        </p:txBody>
+      </p:sp>
+      <p:sp>
+        <p:nvSpPr>
+          <p:cNvPr id="28" name="Text 26"/>
+          <p:cNvSpPr/>
+          <p:nvPr/>
+        </p:nvSpPr>
+        <p:spPr>
+          <a:xfrm>
+            <a:off x="5501580" y="1069628"/>
+            <a:ext cx="1554510" cy="2686050"/>
+          </a:xfrm>
+          <a:prstGeom prst="roundRect">
+            <a:avLst>
+              <a:gd name="adj" fmla="val 8170"/>
+            </a:avLst>
+          </a:prstGeom>
+          <a:solidFill>
+            <a:srgbClr val="FFFFFF"/>
+          </a:solidFill>
+          <a:ln/>
+        </p:spPr>
+        <p:txBody>
+          <a:bodyPr wrap="square" rtlCol="0" anchor="ctr"/>
+          <a:lstStyle/>
+          <a:p>
+            <a:pPr indent="0" marL="0">
+              <a:buNone/>
+            </a:pPr>
+            <a:endParaRPr lang="en-US" dirty="0"/>
+          </a:p>
+        </p:txBody>
+      </p:sp>
+      <p:sp>
+        <p:nvSpPr>
+          <p:cNvPr id="29" name="Shape 27"/>
+          <p:cNvSpPr/>
+          <p:nvPr/>
+        </p:nvSpPr>
+        <p:spPr>
+          <a:xfrm>
+            <a:off x="5501580" y="1093440"/>
+            <a:ext cx="1554510" cy="0"/>
+          </a:xfrm>
+          <a:prstGeom prst="line">
+            <a:avLst/>
+          </a:prstGeom>
+          <a:noFill/>
+          <a:ln w="47625">
+            <a:solidFill>
+              <a:srgbClr val="0E8C84"/>
+            </a:solidFill>
+            <a:prstDash val="solid"/>
+          </a:ln>
+        </p:spPr>
+      </p:sp>
+      <p:sp>
+        <p:nvSpPr>
+          <p:cNvPr id="30" name="Shape 28"/>
+          <p:cNvSpPr/>
+          <p:nvPr/>
+        </p:nvSpPr>
+        <p:spPr>
+          <a:xfrm>
+            <a:off x="7051328" y="1069628"/>
+            <a:ext cx="0" cy="2686050"/>
+          </a:xfrm>
+          <a:prstGeom prst="line">
+            <a:avLst/>
+          </a:prstGeom>
+          <a:noFill/>
+          <a:ln w="9525">
+            <a:solidFill>
+              <a:srgbClr val="D9E8E4"/>
+            </a:solidFill>
+            <a:prstDash val="solid"/>
+          </a:ln>
+        </p:spPr>
+      </p:sp>
+      <p:sp>
+        <p:nvSpPr>
+          <p:cNvPr id="31" name="Shape 29"/>
+          <p:cNvSpPr/>
+          <p:nvPr/>
+        </p:nvSpPr>
+        <p:spPr>
+          <a:xfrm>
+            <a:off x="5501580" y="3750915"/>
+            <a:ext cx="1554510" cy="0"/>
+          </a:xfrm>
+          <a:prstGeom prst="line">
+            <a:avLst/>
+          </a:prstGeom>
+          <a:noFill/>
+          <a:ln w="9525">
+            <a:solidFill>
+              <a:srgbClr val="D9E8E4"/>
+            </a:solidFill>
+            <a:prstDash val="solid"/>
+          </a:ln>
+        </p:spPr>
+      </p:sp>
+      <p:sp>
+        <p:nvSpPr>
+          <p:cNvPr id="32" name="Shape 30"/>
+          <p:cNvSpPr/>
+          <p:nvPr/>
+        </p:nvSpPr>
+        <p:spPr>
+          <a:xfrm>
+            <a:off x="5506343" y="1069628"/>
+            <a:ext cx="0" cy="2686050"/>
+          </a:xfrm>
+          <a:prstGeom prst="line">
+            <a:avLst/>
+          </a:prstGeom>
+          <a:noFill/>
+          <a:ln w="9525">
+            <a:solidFill>
+              <a:srgbClr val="D9E8E4"/>
+            </a:solidFill>
+            <a:prstDash val="solid"/>
+          </a:ln>
+        </p:spPr>
+      </p:sp>
+      <p:sp>
+        <p:nvSpPr>
+          <p:cNvPr id="33" name="Text 31"/>
+          <p:cNvSpPr/>
+          <p:nvPr/>
+        </p:nvSpPr>
+        <p:spPr>
+          <a:xfrm>
+            <a:off x="5663505" y="1269653"/>
+            <a:ext cx="1255273" cy="238125"/>
+          </a:xfrm>
+          <a:prstGeom prst="rect">
+            <a:avLst/>
+          </a:prstGeom>
+          <a:noFill/>
+          <a:ln/>
+        </p:spPr>
+        <p:txBody>
+          <a:bodyPr wrap="square" lIns="0" tIns="0" rIns="0" bIns="0" rtlCol="0" anchor="t"/>
+          <a:lstStyle/>
+          <a:p>
+            <a:pPr algn="l" indent="0" marL="0">
+              <a:buNone/>
+            </a:pPr>
+            <a:r>
+              <a:rPr lang="en-US" sz="1600" b="1" dirty="0">
+                <a:solidFill>
+                  <a:srgbClr val="34D399"/>
+                </a:solidFill>
+                <a:latin typeface="Arial" pitchFamily="34" charset="0"/>
+                <a:ea typeface="Arial" pitchFamily="34" charset="-122"/>
+                <a:cs typeface="Arial" pitchFamily="34" charset="-120"/>
+              </a:rPr>
+              <a:t>04</a:t>
+            </a:r>
+            <a:endParaRPr lang="en-US" sz="1600" dirty="0"/>
+          </a:p>
+        </p:txBody>
+      </p:sp>
+      <p:sp>
+        <p:nvSpPr>
+          <p:cNvPr id="34" name="Text 32"/>
+          <p:cNvSpPr/>
+          <p:nvPr/>
+        </p:nvSpPr>
+        <p:spPr>
+          <a:xfrm>
+            <a:off x="5663505" y="1571179"/>
+            <a:ext cx="1255273" cy="349151"/>
+          </a:xfrm>
+          <a:prstGeom prst="rect">
+            <a:avLst/>
+          </a:prstGeom>
+          <a:noFill/>
+          <a:ln/>
+        </p:spPr>
+        <p:txBody>
+          <a:bodyPr wrap="square" lIns="0" tIns="0" rIns="0" bIns="0" rtlCol="0" anchor="t"/>
+          <a:lstStyle/>
+          <a:p>
+            <a:pPr algn="l" indent="0" marL="0">
+              <a:lnSpc>
+                <a:spcPts val="1375"/>
+              </a:lnSpc>
+              <a:spcBef>
+                <a:spcPts val="500"/>
+              </a:spcBef>
+              <a:buNone/>
+            </a:pPr>
+            <a:r>
+              <a:rPr lang="en-US" sz="1100" b="1" dirty="0">
+                <a:solidFill>
+                  <a:srgbClr val="0B5E5C"/>
+                </a:solidFill>
+                <a:latin typeface="Arial" pitchFamily="34" charset="0"/>
+                <a:ea typeface="Arial" pitchFamily="34" charset="-122"/>
+                <a:cs typeface="Arial" pitchFamily="34" charset="-120"/>
+              </a:rPr>
+              <a:t>Khép kín phản hồi → hành động</a:t>
+            </a:r>
+            <a:endParaRPr lang="en-US" sz="1100" dirty="0"/>
+          </a:p>
+        </p:txBody>
+      </p:sp>
+      <p:sp>
+        <p:nvSpPr>
+          <p:cNvPr id="35" name="Text 33"/>
+          <p:cNvSpPr/>
+          <p:nvPr/>
+        </p:nvSpPr>
+        <p:spPr>
+          <a:xfrm>
+            <a:off x="5663505" y="1983730"/>
+            <a:ext cx="1255273" cy="297061"/>
+          </a:xfrm>
+          <a:prstGeom prst="rect">
+            <a:avLst/>
+          </a:prstGeom>
+          <a:noFill/>
+          <a:ln/>
+        </p:spPr>
+        <p:txBody>
+          <a:bodyPr wrap="square" lIns="0" tIns="0" rIns="0" bIns="0" rtlCol="0" anchor="t"/>
+          <a:lstStyle/>
+          <a:p>
+            <a:pPr algn="l" indent="0" marL="0">
+              <a:lnSpc>
+                <a:spcPts val="1170"/>
+              </a:lnSpc>
+              <a:spcBef>
+                <a:spcPts val="500"/>
+              </a:spcBef>
+              <a:buNone/>
+            </a:pPr>
+            <a:r>
+              <a:rPr lang="en-US" sz="900" dirty="0">
+                <a:solidFill>
+                  <a:srgbClr val="5C7470"/>
+                </a:solidFill>
+                <a:latin typeface="Arial" pitchFamily="34" charset="0"/>
+                <a:ea typeface="Arial" pitchFamily="34" charset="-122"/>
+                <a:cs typeface="Arial" pitchFamily="34" charset="-120"/>
+              </a:rPr>
+              <a:t>Mọi phân tích phải dẫn tới việc được giao.</a:t>
+            </a:r>
+            <a:endParaRPr lang="en-US" sz="900" dirty="0"/>
+          </a:p>
+        </p:txBody>
+      </p:sp>
+      <p:sp>
+        <p:nvSpPr>
+          <p:cNvPr id="36" name="Text 34"/>
+          <p:cNvSpPr/>
+          <p:nvPr/>
+        </p:nvSpPr>
+        <p:spPr>
+          <a:xfrm>
+            <a:off x="7208490" y="1069628"/>
+            <a:ext cx="1554510" cy="2686050"/>
+          </a:xfrm>
+          <a:prstGeom prst="roundRect">
+            <a:avLst>
+              <a:gd name="adj" fmla="val 8170"/>
+            </a:avLst>
+          </a:prstGeom>
+          <a:solidFill>
+            <a:srgbClr val="FFFFFF"/>
+          </a:solidFill>
+          <a:ln/>
+        </p:spPr>
+        <p:txBody>
+          <a:bodyPr wrap="square" rtlCol="0" anchor="ctr"/>
+          <a:lstStyle/>
+          <a:p>
+            <a:pPr indent="0" marL="0">
+              <a:buNone/>
+            </a:pPr>
+            <a:endParaRPr lang="en-US" dirty="0"/>
+          </a:p>
+        </p:txBody>
+      </p:sp>
+      <p:sp>
+        <p:nvSpPr>
+          <p:cNvPr id="37" name="Shape 35"/>
+          <p:cNvSpPr/>
+          <p:nvPr/>
+        </p:nvSpPr>
+        <p:spPr>
+          <a:xfrm>
+            <a:off x="7208490" y="1093440"/>
+            <a:ext cx="1554510" cy="0"/>
+          </a:xfrm>
+          <a:prstGeom prst="line">
+            <a:avLst/>
+          </a:prstGeom>
+          <a:noFill/>
+          <a:ln w="47625">
+            <a:solidFill>
+              <a:srgbClr val="0E8C84"/>
+            </a:solidFill>
+            <a:prstDash val="solid"/>
+          </a:ln>
+        </p:spPr>
+      </p:sp>
+      <p:sp>
+        <p:nvSpPr>
+          <p:cNvPr id="38" name="Shape 36"/>
+          <p:cNvSpPr/>
+          <p:nvPr/>
+        </p:nvSpPr>
+        <p:spPr>
+          <a:xfrm>
+            <a:off x="8758238" y="1069628"/>
+            <a:ext cx="0" cy="2686050"/>
+          </a:xfrm>
+          <a:prstGeom prst="line">
+            <a:avLst/>
+          </a:prstGeom>
+          <a:noFill/>
+          <a:ln w="9525">
+            <a:solidFill>
+              <a:srgbClr val="D9E8E4"/>
+            </a:solidFill>
+            <a:prstDash val="solid"/>
+          </a:ln>
+        </p:spPr>
+      </p:sp>
+      <p:sp>
+        <p:nvSpPr>
+          <p:cNvPr id="39" name="Shape 37"/>
+          <p:cNvSpPr/>
+          <p:nvPr/>
+        </p:nvSpPr>
+        <p:spPr>
+          <a:xfrm>
+            <a:off x="7208490" y="3750915"/>
+            <a:ext cx="1554510" cy="0"/>
+          </a:xfrm>
+          <a:prstGeom prst="line">
+            <a:avLst/>
+          </a:prstGeom>
+          <a:noFill/>
+          <a:ln w="9525">
+            <a:solidFill>
+              <a:srgbClr val="D9E8E4"/>
+            </a:solidFill>
+            <a:prstDash val="solid"/>
+          </a:ln>
+        </p:spPr>
+      </p:sp>
+      <p:sp>
+        <p:nvSpPr>
+          <p:cNvPr id="40" name="Shape 38"/>
+          <p:cNvSpPr/>
+          <p:nvPr/>
+        </p:nvSpPr>
+        <p:spPr>
+          <a:xfrm>
+            <a:off x="7213253" y="1069628"/>
+            <a:ext cx="0" cy="2686050"/>
+          </a:xfrm>
+          <a:prstGeom prst="line">
+            <a:avLst/>
+          </a:prstGeom>
+          <a:noFill/>
+          <a:ln w="9525">
+            <a:solidFill>
+              <a:srgbClr val="D9E8E4"/>
+            </a:solidFill>
+            <a:prstDash val="solid"/>
+          </a:ln>
+        </p:spPr>
+      </p:sp>
+      <p:sp>
+        <p:nvSpPr>
+          <p:cNvPr id="41" name="Text 39"/>
+          <p:cNvSpPr/>
+          <p:nvPr/>
+        </p:nvSpPr>
+        <p:spPr>
+          <a:xfrm>
+            <a:off x="7370415" y="1269653"/>
+            <a:ext cx="1255273" cy="238125"/>
+          </a:xfrm>
+          <a:prstGeom prst="rect">
+            <a:avLst/>
+          </a:prstGeom>
+          <a:noFill/>
+          <a:ln/>
+        </p:spPr>
+        <p:txBody>
+          <a:bodyPr wrap="square" lIns="0" tIns="0" rIns="0" bIns="0" rtlCol="0" anchor="t"/>
+          <a:lstStyle/>
+          <a:p>
+            <a:pPr algn="l" indent="0" marL="0">
+              <a:buNone/>
+            </a:pPr>
+            <a:r>
+              <a:rPr lang="en-US" sz="1600" b="1" dirty="0">
+                <a:solidFill>
+                  <a:srgbClr val="34D399"/>
+                </a:solidFill>
+                <a:latin typeface="Arial" pitchFamily="34" charset="0"/>
+                <a:ea typeface="Arial" pitchFamily="34" charset="-122"/>
+                <a:cs typeface="Arial" pitchFamily="34" charset="-120"/>
+              </a:rPr>
+              <a:t>05</a:t>
+            </a:r>
+            <a:endParaRPr lang="en-US" sz="1600" dirty="0"/>
+          </a:p>
+        </p:txBody>
+      </p:sp>
+      <p:sp>
+        <p:nvSpPr>
+          <p:cNvPr id="42" name="Text 40"/>
+          <p:cNvSpPr/>
+          <p:nvPr/>
+        </p:nvSpPr>
+        <p:spPr>
+          <a:xfrm>
+            <a:off x="7370415" y="1571179"/>
+            <a:ext cx="1255273" cy="174575"/>
+          </a:xfrm>
+          <a:prstGeom prst="rect">
+            <a:avLst/>
+          </a:prstGeom>
+          <a:noFill/>
+          <a:ln/>
+        </p:spPr>
+        <p:txBody>
+          <a:bodyPr wrap="square" lIns="0" tIns="0" rIns="0" bIns="0" rtlCol="0" anchor="t"/>
+          <a:lstStyle/>
+          <a:p>
+            <a:pPr algn="l" indent="0" marL="0">
+              <a:lnSpc>
+                <a:spcPts val="1375"/>
+              </a:lnSpc>
+              <a:spcBef>
+                <a:spcPts val="500"/>
+              </a:spcBef>
+              <a:buNone/>
+            </a:pPr>
+            <a:r>
+              <a:rPr lang="en-US" sz="1100" b="1" dirty="0">
+                <a:solidFill>
+                  <a:srgbClr val="0B5E5C"/>
+                </a:solidFill>
+                <a:latin typeface="Arial" pitchFamily="34" charset="0"/>
+                <a:ea typeface="Arial" pitchFamily="34" charset="-122"/>
+                <a:cs typeface="Arial" pitchFamily="34" charset="-120"/>
+              </a:rPr>
+              <a:t>Realtime-first</a:t>
+            </a:r>
+            <a:endParaRPr lang="en-US" sz="1100" dirty="0"/>
+          </a:p>
+        </p:txBody>
+      </p:sp>
+      <p:sp>
+        <p:nvSpPr>
+          <p:cNvPr id="43" name="Text 41"/>
+          <p:cNvSpPr/>
+          <p:nvPr/>
+        </p:nvSpPr>
+        <p:spPr>
+          <a:xfrm>
+            <a:off x="7370415" y="1809155"/>
+            <a:ext cx="1255273" cy="445591"/>
+          </a:xfrm>
+          <a:prstGeom prst="rect">
+            <a:avLst/>
+          </a:prstGeom>
+          <a:noFill/>
+          <a:ln/>
+        </p:spPr>
+        <p:txBody>
+          <a:bodyPr wrap="square" lIns="0" tIns="0" rIns="0" bIns="0" rtlCol="0" anchor="t"/>
+          <a:lstStyle/>
+          <a:p>
+            <a:pPr algn="l" indent="0" marL="0">
+              <a:lnSpc>
+                <a:spcPts val="1170"/>
+              </a:lnSpc>
+              <a:spcBef>
+                <a:spcPts val="500"/>
+              </a:spcBef>
+              <a:buNone/>
+            </a:pPr>
+            <a:r>
+              <a:rPr lang="en-US" sz="900" dirty="0">
+                <a:solidFill>
+                  <a:srgbClr val="5C7470"/>
+                </a:solidFill>
+                <a:latin typeface="Arial" pitchFamily="34" charset="0"/>
+                <a:ea typeface="Arial" pitchFamily="34" charset="-122"/>
+                <a:cs typeface="Arial" pitchFamily="34" charset="-120"/>
+              </a:rPr>
+              <a:t>Thấy vấn đề khi nó đang xảy ra, không phải hôm sau.</a:t>
+            </a:r>
+            <a:endParaRPr lang="en-US" sz="900" dirty="0"/>
+          </a:p>
+        </p:txBody>
+      </p:sp>
+      <p:sp>
+        <p:nvSpPr>
+          <p:cNvPr id="44" name="Text 42"/>
+          <p:cNvSpPr/>
+          <p:nvPr/>
+        </p:nvSpPr>
+        <p:spPr>
+          <a:xfrm>
+            <a:off x="381000" y="3958828"/>
+            <a:ext cx="8382000" cy="714970"/>
+          </a:xfrm>
+          <a:prstGeom prst="roundRect">
+            <a:avLst>
+              <a:gd name="adj" fmla="val 17763"/>
+            </a:avLst>
+          </a:prstGeom>
+          <a:solidFill>
+            <a:srgbClr val="FFFFFF"/>
+          </a:solidFill>
+          <a:ln/>
+        </p:spPr>
+        <p:txBody>
+          <a:bodyPr wrap="square" rtlCol="0" anchor="ctr"/>
+          <a:lstStyle/>
+          <a:p>
+            <a:pPr indent="0" marL="0">
+              <a:buNone/>
+            </a:pPr>
+            <a:endParaRPr lang="en-US" dirty="0"/>
+          </a:p>
+        </p:txBody>
+      </p:sp>
+      <p:sp>
+        <p:nvSpPr>
+          <p:cNvPr id="45" name="Shape 43"/>
+          <p:cNvSpPr/>
+          <p:nvPr/>
+        </p:nvSpPr>
+        <p:spPr>
+          <a:xfrm>
+            <a:off x="381000" y="3963591"/>
+            <a:ext cx="8382000" cy="0"/>
+          </a:xfrm>
+          <a:prstGeom prst="line">
+            <a:avLst/>
+          </a:prstGeom>
+          <a:noFill/>
+          <a:ln w="9525">
+            <a:solidFill>
+              <a:srgbClr val="D9E8E4"/>
+            </a:solidFill>
+            <a:prstDash val="solid"/>
+          </a:ln>
+        </p:spPr>
+      </p:sp>
+      <p:sp>
+        <p:nvSpPr>
+          <p:cNvPr id="46" name="Shape 44"/>
+          <p:cNvSpPr/>
+          <p:nvPr/>
+        </p:nvSpPr>
+        <p:spPr>
+          <a:xfrm>
+            <a:off x="8758237" y="3958828"/>
+            <a:ext cx="0" cy="714970"/>
+          </a:xfrm>
+          <a:prstGeom prst="line">
+            <a:avLst/>
+          </a:prstGeom>
+          <a:noFill/>
+          <a:ln w="9525">
+            <a:solidFill>
+              <a:srgbClr val="D9E8E4"/>
+            </a:solidFill>
+            <a:prstDash val="solid"/>
+          </a:ln>
+        </p:spPr>
+      </p:sp>
+      <p:sp>
+        <p:nvSpPr>
+          <p:cNvPr id="47" name="Shape 45"/>
+          <p:cNvSpPr/>
+          <p:nvPr/>
+        </p:nvSpPr>
+        <p:spPr>
+          <a:xfrm>
+            <a:off x="381000" y="4669036"/>
+            <a:ext cx="8382000" cy="0"/>
+          </a:xfrm>
+          <a:prstGeom prst="line">
+            <a:avLst/>
+          </a:prstGeom>
+          <a:noFill/>
+          <a:ln w="9525">
+            <a:solidFill>
+              <a:srgbClr val="D9E8E4"/>
+            </a:solidFill>
+            <a:prstDash val="solid"/>
+          </a:ln>
+        </p:spPr>
+      </p:sp>
+      <p:sp>
+        <p:nvSpPr>
+          <p:cNvPr id="48" name="Shape 46"/>
+          <p:cNvSpPr/>
+          <p:nvPr/>
+        </p:nvSpPr>
+        <p:spPr>
+          <a:xfrm>
+            <a:off x="409575" y="3958828"/>
+            <a:ext cx="0" cy="714970"/>
+          </a:xfrm>
+          <a:prstGeom prst="line">
+            <a:avLst/>
+          </a:prstGeom>
+          <a:noFill/>
+          <a:ln w="57150">
+            <a:solidFill>
+              <a:srgbClr val="34D399"/>
+            </a:solidFill>
+            <a:prstDash val="solid"/>
+          </a:ln>
+        </p:spPr>
+      </p:sp>
+      <p:sp>
+        <p:nvSpPr>
+          <p:cNvPr id="49" name="Text 47"/>
+          <p:cNvSpPr/>
+          <p:nvPr/>
+        </p:nvSpPr>
+        <p:spPr>
+          <a:xfrm>
+            <a:off x="590550" y="4120753"/>
+            <a:ext cx="8170736" cy="391120"/>
+          </a:xfrm>
+          <a:prstGeom prst="rect">
+            <a:avLst/>
+          </a:prstGeom>
+          <a:noFill/>
+          <a:ln/>
+        </p:spPr>
+        <p:txBody>
+          <a:bodyPr wrap="square" lIns="0" tIns="0" rIns="0" bIns="0" rtlCol="0" anchor="t"/>
+          <a:lstStyle/>
+          <a:p>
+            <a:pPr algn="l" indent="0" marL="0">
+              <a:lnSpc>
+                <a:spcPts val="1540"/>
+              </a:lnSpc>
+              <a:buNone/>
+            </a:pPr>
+            <a:r>
+              <a:rPr lang="en-US" sz="1100" dirty="0">
+                <a:solidFill>
+                  <a:srgbClr val="0E2B29"/>
+                </a:solidFill>
+                <a:latin typeface="Arial" pitchFamily="34" charset="0"/>
+                <a:ea typeface="Arial" pitchFamily="34" charset="-122"/>
+                <a:cs typeface="Arial" pitchFamily="34" charset="-120"/>
+              </a:rPr>
+              <a:t>Sản phẩm không dừng ở "phân loại đúng" — nó được thiết kế để </a:t>
+            </a:r>
+            <a:pPr algn="l" indent="0" marL="0">
+              <a:lnSpc>
+                <a:spcPts val="1540"/>
+              </a:lnSpc>
+              <a:buNone/>
+            </a:pPr>
+            <a:r>
+              <a:rPr lang="en-US" sz="1100" b="1" dirty="0">
+                <a:solidFill>
+                  <a:srgbClr val="0E2B29"/>
+                </a:solidFill>
+                <a:latin typeface="Arial" pitchFamily="34" charset="0"/>
+                <a:ea typeface="Arial" pitchFamily="34" charset="-122"/>
+                <a:cs typeface="Arial" pitchFamily="34" charset="-120"/>
+              </a:rPr>
+              <a:t>rút ngắn khoảng cách giữa một lời phàn nàn và một hành động khắc phục</a:t>
+            </a:r>
+            <a:pPr algn="l" indent="0" marL="0">
+              <a:lnSpc>
+                <a:spcPts val="1540"/>
+              </a:lnSpc>
+              <a:buNone/>
+            </a:pPr>
+            <a:r>
+              <a:rPr lang="en-US" sz="1100" dirty="0">
+                <a:solidFill>
+                  <a:srgbClr val="0E2B29"/>
+                </a:solidFill>
+                <a:latin typeface="Arial" pitchFamily="34" charset="0"/>
+                <a:ea typeface="Arial" pitchFamily="34" charset="-122"/>
+                <a:cs typeface="Arial" pitchFamily="34" charset="-120"/>
+              </a:rPr>
+              <a:t>.</a:t>
+            </a:r>
+            <a:endParaRPr lang="en-US" sz="1100" dirty="0"/>
+          </a:p>
+        </p:txBody>
+      </p:sp>
+      <p:sp>
+        <p:nvSpPr>
+          <p:cNvPr id="50" name="Text 48"/>
+          <p:cNvSpPr/>
+          <p:nvPr/>
+        </p:nvSpPr>
+        <p:spPr>
+          <a:xfrm>
+            <a:off x="381000" y="4673798"/>
+            <a:ext cx="8549640" cy="114300"/>
+          </a:xfrm>
+          <a:prstGeom prst="rect">
+            <a:avLst/>
+          </a:prstGeom>
+          <a:noFill/>
+          <a:ln/>
+        </p:spPr>
+        <p:txBody>
+          <a:bodyPr wrap="square" lIns="0" tIns="0" rIns="0" bIns="0" rtlCol="0" anchor="t"/>
+          <a:lstStyle/>
+          <a:p>
+            <a:pPr algn="l" indent="0" marL="0">
+              <a:spcAft>
+                <a:spcPts val="800"/>
+              </a:spcAft>
+              <a:buNone/>
+            </a:pPr>
+            <a:r>
+              <a:rPr lang="en-US" sz="800" dirty="0">
+                <a:solidFill>
+                  <a:srgbClr val="5C7470"/>
+                </a:solidFill>
+                <a:latin typeface="Arial" pitchFamily="34" charset="0"/>
+                <a:ea typeface="Arial" pitchFamily="34" charset="-122"/>
+                <a:cs typeface="Arial" pitchFamily="34" charset="-120"/>
+              </a:rPr>
+              <a:t>xanhSM · AI Quality Intelligence Platform · AI20K Cohort 2 — Team 116</a:t>
+            </a:r>
+            <a:endParaRPr lang="en-US" sz="800" dirty="0"/>
+          </a:p>
+        </p:txBody>
+      </p:sp>
+    </p:spTree>
+  </p:cSld>
+  <p:clrMapOvr>
+    <a:masterClrMapping/>
+  </p:clrMapOvr>
+</p:sld>
+</file>
+
+<file path=ppt/slides/slide16.xml><?xml version="1.0" encoding="utf-8"?>
+<p:sld xmlns:a="http://schemas.openxmlformats.org/drawingml/2006/main" xmlns:r="http://schemas.openxmlformats.org/officeDocument/2006/relationships" xmlns:p="http://schemas.openxmlformats.org/presentationml/2006/main">
+  <p:cSld name="Slide 16">
+    <p:bg>
+      <p:bgPr>
+        <a:solidFill>
+          <a:srgbClr val="FFFFFF"/>
+        </a:solidFill>
+      </p:bgPr>
+    </p:bg>
+    <p:spTree>
+      <p:nvGrpSpPr>
+        <p:cNvPr id="1" name=""/>
+        <p:cNvGrpSpPr/>
+        <p:nvPr/>
+      </p:nvGrpSpPr>
+      <p:grpSpPr>
+        <a:xfrm>
+          <a:off x="0" y="0"/>
+          <a:ext cx="0" cy="0"/>
+          <a:chOff x="0" y="0"/>
+          <a:chExt cx="0" cy="0"/>
+        </a:xfrm>
+      </p:grpSpPr>
+      <p:sp>
+        <p:nvSpPr>
+          <p:cNvPr id="2" name="Text 0"/>
+          <p:cNvSpPr/>
+          <p:nvPr/>
+        </p:nvSpPr>
+        <p:spPr>
+          <a:xfrm>
+            <a:off x="381000" y="330101"/>
+            <a:ext cx="8549640" cy="142875"/>
+          </a:xfrm>
+          <a:prstGeom prst="rect">
+            <a:avLst/>
+          </a:prstGeom>
+          <a:noFill/>
+          <a:ln/>
+        </p:spPr>
+        <p:txBody>
+          <a:bodyPr wrap="square" lIns="0" tIns="0" rIns="0" bIns="0" rtlCol="0" anchor="t"/>
+          <a:lstStyle/>
+          <a:p>
+            <a:pPr algn="l" indent="0" marL="0">
+              <a:spcAft>
+                <a:spcPts val="400"/>
+              </a:spcAft>
+              <a:buNone/>
+            </a:pPr>
+            <a:r>
+              <a:rPr lang="en-US" sz="1000" b="1" dirty="0">
+                <a:solidFill>
+                  <a:srgbClr val="0E8C84"/>
+                </a:solidFill>
+                <a:latin typeface="Arial" pitchFamily="34" charset="0"/>
+                <a:ea typeface="Arial" pitchFamily="34" charset="-122"/>
+                <a:cs typeface="Arial" pitchFamily="34" charset="-120"/>
+              </a:rPr>
+              <a:t>KẾT QUẢ &amp; ROADMAP</a:t>
+            </a:r>
+            <a:endParaRPr lang="en-US" sz="1000" dirty="0"/>
+          </a:p>
+        </p:txBody>
+      </p:sp>
+      <p:sp>
+        <p:nvSpPr>
+          <p:cNvPr id="3" name="Text 1"/>
+          <p:cNvSpPr/>
+          <p:nvPr/>
+        </p:nvSpPr>
+        <p:spPr>
+          <a:xfrm>
+            <a:off x="381000" y="523726"/>
+            <a:ext cx="8549640" cy="342751"/>
+          </a:xfrm>
+          <a:prstGeom prst="rect">
+            <a:avLst/>
+          </a:prstGeom>
+          <a:noFill/>
+          <a:ln/>
+        </p:spPr>
+        <p:txBody>
+          <a:bodyPr wrap="square" lIns="0" tIns="0" rIns="0" bIns="0" rtlCol="0" anchor="t"/>
+          <a:lstStyle/>
+          <a:p>
+            <a:pPr algn="l" indent="0" marL="0">
+              <a:lnSpc>
+                <a:spcPts val="2700"/>
+              </a:lnSpc>
+              <a:buNone/>
+            </a:pPr>
+            <a:r>
+              <a:rPr lang="en-US" sz="2500" b="1" dirty="0">
+                <a:solidFill>
+                  <a:srgbClr val="0B5E5C"/>
+                </a:solidFill>
+                <a:latin typeface="Arial" pitchFamily="34" charset="0"/>
+                <a:ea typeface="Arial" pitchFamily="34" charset="-122"/>
+                <a:cs typeface="Arial" pitchFamily="34" charset="-120"/>
+              </a:rPr>
+              <a:t>Đã hoàn thiện vòng khép kín, sẵn sàng mở rộng</a:t>
+            </a:r>
+            <a:endParaRPr lang="en-US" sz="2500" dirty="0"/>
+          </a:p>
+        </p:txBody>
+      </p:sp>
+      <p:sp>
+        <p:nvSpPr>
+          <p:cNvPr id="4" name="Text 2"/>
+          <p:cNvSpPr/>
+          <p:nvPr/>
+        </p:nvSpPr>
+        <p:spPr>
+          <a:xfrm>
+            <a:off x="381000" y="1095077"/>
+            <a:ext cx="3048149" cy="1946672"/>
+          </a:xfrm>
+          <a:prstGeom prst="rect">
+            <a:avLst/>
+          </a:prstGeom>
+          <a:noFill/>
+          <a:ln/>
+        </p:spPr>
+        <p:txBody>
+          <a:bodyPr wrap="square" lIns="88900" tIns="0" rIns="0" bIns="0" rtlCol="0" anchor="t"/>
+          <a:lstStyle/>
+          <a:p>
+            <a:pPr algn="l" marL="88900" indent="-88900">
+              <a:lnSpc>
+                <a:spcPts val="1667"/>
+              </a:lnSpc>
+              <a:spcAft>
+                <a:spcPts val="500"/>
+              </a:spcAft>
+              <a:buSzPct val="100000"/>
+              <a:buChar char="•"/>
+            </a:pPr>
+            <a:r>
+              <a:rPr lang="en-US" sz="1150" b="1" dirty="0">
+                <a:solidFill>
+                  <a:srgbClr val="0E2B29"/>
+                </a:solidFill>
+                <a:latin typeface="Arial" pitchFamily="34" charset="0"/>
+                <a:ea typeface="Arial" pitchFamily="34" charset="-122"/>
+                <a:cs typeface="Arial" pitchFamily="34" charset="-120"/>
+              </a:rPr>
+              <a:t>Đã có:</a:t>
+            </a:r>
+            <a:pPr algn="l" indent="0" marL="0">
+              <a:lnSpc>
+                <a:spcPts val="1667"/>
+              </a:lnSpc>
+              <a:spcAft>
+                <a:spcPts val="500"/>
+              </a:spcAft>
+              <a:buNone/>
+            </a:pPr>
+            <a:r>
+              <a:rPr lang="en-US" sz="1150" dirty="0">
+                <a:solidFill>
+                  <a:srgbClr val="0E2B29"/>
+                </a:solidFill>
+                <a:latin typeface="Arial" pitchFamily="34" charset="0"/>
+                <a:ea typeface="Arial" pitchFamily="34" charset="-122"/>
+                <a:cs typeface="Arial" pitchFamily="34" charset="-120"/>
+              </a:rPr>
+              <a:t> task loop, Human-in-the-loop, RAG hybrid, định tuyến 6 phòng.</a:t>
+            </a:r>
+            <a:endParaRPr lang="en-US" sz="1150" dirty="0"/>
+          </a:p>
+          <a:p>
+            <a:pPr algn="l" marL="88900" indent="-88900">
+              <a:lnSpc>
+                <a:spcPts val="1667"/>
+              </a:lnSpc>
+              <a:spcAft>
+                <a:spcPts val="500"/>
+              </a:spcAft>
+              <a:buSzPct val="100000"/>
+              <a:buChar char="•"/>
+            </a:pPr>
+            <a:r>
+              <a:rPr lang="en-US" sz="1150" b="1" dirty="0">
+                <a:solidFill>
+                  <a:srgbClr val="0E2B29"/>
+                </a:solidFill>
+                <a:latin typeface="Arial" pitchFamily="34" charset="0"/>
+                <a:ea typeface="Arial" pitchFamily="34" charset="-122"/>
+                <a:cs typeface="Arial" pitchFamily="34" charset="-120"/>
+              </a:rPr>
+              <a:t>Realtime:</a:t>
+            </a:r>
+            <a:pPr algn="l" indent="0" marL="0">
+              <a:lnSpc>
+                <a:spcPts val="1667"/>
+              </a:lnSpc>
+              <a:spcAft>
+                <a:spcPts val="500"/>
+              </a:spcAft>
+              <a:buNone/>
+            </a:pPr>
+            <a:r>
+              <a:rPr lang="en-US" sz="1150" dirty="0">
+                <a:solidFill>
+                  <a:srgbClr val="0E2B29"/>
+                </a:solidFill>
+                <a:latin typeface="Arial" pitchFamily="34" charset="0"/>
+                <a:ea typeface="Arial" pitchFamily="34" charset="-122"/>
+                <a:cs typeface="Arial" pitchFamily="34" charset="-120"/>
+              </a:rPr>
+              <a:t> streaming ~50 review/giây + scheduler tự sinh alert/ticket.</a:t>
+            </a:r>
+            <a:endParaRPr lang="en-US" sz="1150" dirty="0"/>
+          </a:p>
+          <a:p>
+            <a:pPr algn="l" marL="88900" indent="-88900">
+              <a:lnSpc>
+                <a:spcPts val="1667"/>
+              </a:lnSpc>
+              <a:spcAft>
+                <a:spcPts val="500"/>
+              </a:spcAft>
+              <a:buSzPct val="100000"/>
+              <a:buChar char="•"/>
+            </a:pPr>
+            <a:r>
+              <a:rPr lang="en-US" sz="1150" b="1" dirty="0">
+                <a:solidFill>
+                  <a:srgbClr val="0E2B29"/>
+                </a:solidFill>
+                <a:latin typeface="Arial" pitchFamily="34" charset="0"/>
+                <a:ea typeface="Arial" pitchFamily="34" charset="-122"/>
+                <a:cs typeface="Arial" pitchFamily="34" charset="-120"/>
+              </a:rPr>
+              <a:t>Bằng chứng:</a:t>
+            </a:r>
+            <a:pPr algn="l" indent="0" marL="0">
+              <a:lnSpc>
+                <a:spcPts val="1667"/>
+              </a:lnSpc>
+              <a:spcAft>
+                <a:spcPts val="500"/>
+              </a:spcAft>
+              <a:buNone/>
+            </a:pPr>
+            <a:r>
+              <a:rPr lang="en-US" sz="1150" dirty="0">
+                <a:solidFill>
+                  <a:srgbClr val="0E2B29"/>
+                </a:solidFill>
+                <a:latin typeface="Arial" pitchFamily="34" charset="0"/>
+                <a:ea typeface="Arial" pitchFamily="34" charset="-122"/>
+                <a:cs typeface="Arial" pitchFamily="34" charset="-120"/>
+              </a:rPr>
+              <a:t> chạy trên dữ liệu review tiếng Việt thật từ App Store/Google Play.</a:t>
+            </a:r>
+            <a:endParaRPr lang="en-US" sz="1150" dirty="0"/>
+          </a:p>
+          <a:p>
+            <a:pPr algn="l" marL="88900" indent="-88900">
+              <a:lnSpc>
+                <a:spcPts val="1667"/>
+              </a:lnSpc>
+              <a:spcAft>
+                <a:spcPts val="500"/>
+              </a:spcAft>
+              <a:buSzPct val="100000"/>
+              <a:buChar char="•"/>
+            </a:pPr>
+            <a:r>
+              <a:rPr lang="en-US" sz="1150" b="1" dirty="0">
+                <a:solidFill>
+                  <a:srgbClr val="0E2B29"/>
+                </a:solidFill>
+                <a:latin typeface="Arial" pitchFamily="34" charset="0"/>
+                <a:ea typeface="Arial" pitchFamily="34" charset="-122"/>
+                <a:cs typeface="Arial" pitchFamily="34" charset="-120"/>
+              </a:rPr>
+              <a:t>Tiếp theo:</a:t>
+            </a:r>
+            <a:pPr algn="l" indent="0" marL="0">
+              <a:lnSpc>
+                <a:spcPts val="1667"/>
+              </a:lnSpc>
+              <a:spcAft>
+                <a:spcPts val="500"/>
+              </a:spcAft>
+              <a:buNone/>
+            </a:pPr>
+            <a:r>
+              <a:rPr lang="en-US" sz="1150" dirty="0">
+                <a:solidFill>
+                  <a:srgbClr val="0E2B29"/>
+                </a:solidFill>
+                <a:latin typeface="Arial" pitchFamily="34" charset="0"/>
+                <a:ea typeface="Arial" pitchFamily="34" charset="-122"/>
+                <a:cs typeface="Arial" pitchFamily="34" charset="-120"/>
+              </a:rPr>
+              <a:t> mở rộng KB nội bộ cho 6 phòng, tinh chỉnh ML &amp; đánh giá agent.</a:t>
+            </a:r>
+            <a:endParaRPr lang="en-US" sz="1150" dirty="0"/>
+          </a:p>
+        </p:txBody>
+      </p:sp>
+      <p:sp>
+        <p:nvSpPr>
+          <p:cNvPr id="5" name="Text 3"/>
+          <p:cNvSpPr/>
+          <p:nvPr/>
+        </p:nvSpPr>
+        <p:spPr>
+          <a:xfrm>
+            <a:off x="3632299" y="1018877"/>
+            <a:ext cx="5130701" cy="3262759"/>
+          </a:xfrm>
+          <a:prstGeom prst="roundRect">
+            <a:avLst>
+              <a:gd name="adj" fmla="val 3892"/>
+            </a:avLst>
+          </a:prstGeom>
+          <a:solidFill>
+            <a:srgbClr val="FFFFFF"/>
+          </a:solidFill>
+          <a:ln w="9525">
+            <a:solidFill>
+              <a:srgbClr val="D9E8E4"/>
+            </a:solidFill>
+          </a:ln>
+          <a:effectLst>
+            <a:outerShdw sx="100000" sy="100000" kx="0" ky="0" algn="bl" rotWithShape="0" blurRad="133350" dist="47625" dir="3180000">
+              <a:srgbClr val="0b5e5c">
+                <a:alpha val="22000"/>
+              </a:srgbClr>
+            </a:outerShdw>
+          </a:effectLst>
+        </p:spPr>
+        <p:txBody>
+          <a:bodyPr wrap="square" rtlCol="0" anchor="ctr"/>
+          <a:lstStyle/>
+          <a:p>
+            <a:pPr indent="0" marL="0">
+              <a:buNone/>
+            </a:pPr>
+            <a:endParaRPr lang="en-US" dirty="0"/>
+          </a:p>
+        </p:txBody>
+      </p:sp>
+      <p:pic>
+        <p:nvPicPr>
+          <p:cNvPr id="6" name="Image 0" descr="/private/tmp/claude-501/-Users-kenz-de-projects-C2-App-116/3d8df5ac-6b2b-4cce-a997-fe0b4573b465/scratchpad/build/assets/dashboard.png">    </p:cNvPr>
+          <p:cNvPicPr>
+            <a:picLocks noChangeAspect="1"/>
+          </p:cNvPicPr>
+          <p:nvPr/>
+        </p:nvPicPr>
+        <p:blipFill>
+          <a:blip r:embed="rId1"/>
+          <a:stretch>
+            <a:fillRect/>
+          </a:stretch>
+        </p:blipFill>
+        <p:spPr>
+          <a:xfrm>
+            <a:off x="3705225" y="1091803"/>
+            <a:ext cx="4984849" cy="3116907"/>
+          </a:xfrm>
+          <a:prstGeom prst="rect">
+            <a:avLst/>
+          </a:prstGeom>
+        </p:spPr>
+      </p:pic>
+      <p:sp>
+        <p:nvSpPr>
+          <p:cNvPr id="7" name="Text 4"/>
+          <p:cNvSpPr/>
+          <p:nvPr/>
+        </p:nvSpPr>
+        <p:spPr>
+          <a:xfrm>
+            <a:off x="381000" y="4673798"/>
+            <a:ext cx="8549640" cy="114300"/>
+          </a:xfrm>
+          <a:prstGeom prst="rect">
+            <a:avLst/>
+          </a:prstGeom>
+          <a:noFill/>
+          <a:ln/>
+        </p:spPr>
+        <p:txBody>
+          <a:bodyPr wrap="square" lIns="0" tIns="0" rIns="0" bIns="0" rtlCol="0" anchor="t"/>
+          <a:lstStyle/>
+          <a:p>
+            <a:pPr algn="l" indent="0" marL="0">
+              <a:spcAft>
+                <a:spcPts val="800"/>
+              </a:spcAft>
+              <a:buNone/>
+            </a:pPr>
+            <a:r>
+              <a:rPr lang="en-US" sz="800" dirty="0">
+                <a:solidFill>
+                  <a:srgbClr val="5C7470"/>
+                </a:solidFill>
+                <a:latin typeface="Arial" pitchFamily="34" charset="0"/>
+                <a:ea typeface="Arial" pitchFamily="34" charset="-122"/>
+                <a:cs typeface="Arial" pitchFamily="34" charset="-120"/>
+              </a:rPr>
+              <a:t>xanhSM · AI Quality Intelligence Platform · AI20K Cohort 2 — Team 116</a:t>
+            </a:r>
+            <a:endParaRPr lang="en-US" sz="800" dirty="0"/>
+          </a:p>
+        </p:txBody>
+      </p:sp>
+    </p:spTree>
+  </p:cSld>
+  <p:clrMapOvr>
+    <a:masterClrMapping/>
+  </p:clrMapOvr>
+</p:sld>
+</file>
+
+<file path=ppt/slides/slide17.xml><?xml version="1.0" encoding="utf-8"?>
+<p:sld xmlns:a="http://schemas.openxmlformats.org/drawingml/2006/main" xmlns:r="http://schemas.openxmlformats.org/officeDocument/2006/relationships" xmlns:p="http://schemas.openxmlformats.org/presentationml/2006/main">
+  <p:cSld name="Slide 17">
     <p:bg>
       <p:bgPr>
         <a:blipFill dpi="0" rotWithShape="1">

</xml_diff>